<commit_message>
fix: Update shareholder report Word+PPT with SmartMove rename
- generate-report.js: 3Way Sensor → SmartMove
- generate-ppt.js: 3Way Sensor → SmartMove
- Regenerated both .docx and .pptx files

Co-Authored-By: Claude Opus 4.6 (1M context) <noreply@anthropic.com>
</commit_message>
<xml_diff>
--- a/docs/shareholder/WB_App_Renewal_Shareholder_Report_2026.pptx
+++ b/docs/shareholder/WB_App_Renewal_Shareholder_Report_2026.pptx
@@ -6015,7 +6015,7 @@
                 <a:ea typeface="Arial" pitchFamily="34" charset="-122"/>
                 <a:cs typeface="Arial" pitchFamily="34" charset="-120"/>
               </a:rPr>
-              <a:t>3Way Sensor</a:t>
+              <a:t>SmartMove</a:t>
             </a:r>
             <a:endParaRPr lang="en-US" sz="1800" dirty="0"/>
           </a:p>
@@ -7306,7 +7306,7 @@
                 <a:ea typeface="Arial Black" pitchFamily="34" charset="-122"/>
                 <a:cs typeface="Arial Black" pitchFamily="34" charset="-120"/>
               </a:rPr>
-              <a:t>Phase 1: 3Way Sensor + 탄소저감</a:t>
+              <a:t>Phase 1: SmartMove + 탄소저감</a:t>
             </a:r>
             <a:endParaRPr lang="en-US" sz="2800" dirty="0"/>
           </a:p>
@@ -7641,7 +7641,7 @@
                             <a:srgbClr val="1A1A2E"/>
                           </a:solidFill>
                         </a:rPr>
-                        <a:t>3Way Sensor</a:t>
+                        <a:t>SmartMove</a:t>
                       </a:r>
                       <a:endParaRPr lang="en-US" sz="1100" dirty="0"/>
                     </a:p>
@@ -7826,7 +7826,7 @@
                             <a:srgbClr val="1A1A2E"/>
                           </a:solidFill>
                         </a:rPr>
-                        <a:t>3Way Sensor</a:t>
+                        <a:t>SmartMove</a:t>
                       </a:r>
                       <a:endParaRPr lang="en-US" sz="1100" dirty="0"/>
                     </a:p>

</xml_diff>

<commit_message>
docs: Add AI Dev Team section to shareholder report (Word + PPT)
New Section 8: AI 개발팀 구축 효과
- 6 AI teams + 16 QA agents composition table
- Cost savings: 월 3,200만원 → ~20만원 (99.4%, 연 3.6억 절감)
- Speed: 38w → 25.5w (33% faster), QA 75% faster
- Role change: developer → decision maker
- Word: 10 sections (was 9)
- PPT: 11 slides (was 10), new slide with callout cards

Co-Authored-By: Claude Opus 4.6 (1M context) <noreply@anthropic.com>
</commit_message>
<xml_diff>
--- a/docs/shareholder/WB_App_Renewal_Shareholder_Report_2026.pptx
+++ b/docs/shareholder/WB_App_Renewal_Shareholder_Report_2026.pptx
@@ -15,9 +15,10 @@
     <p:sldId id="263" r:id="rId9"/>
     <p:sldId id="264" r:id="rId10"/>
     <p:sldId id="265" r:id="rId11"/>
+    <p:sldId id="266" r:id="rId12"/>
   </p:sldIdLst>
   <p:notesMasterIdLst>
-    <p:notesMasterId r:id="rId12"/>
+    <p:notesMasterId r:id="rId13"/>
   </p:notesMasterIdLst>
   <p:sldSz cx="12192000" cy="6858000"/>
   <p:notesSz cx="6858000" cy="12192000"/>
@@ -623,6 +624,94 @@
             <a:fld id="{F7021451-1387-4CA6-816F-3879F97B5CBC}" type="slidenum">
               <a:rPr lang="en-US"/>
               <a:t>10</a:t>
+            </a:fld>
+            <a:endParaRPr lang="en-US"/>
+          </a:p>
+        </p:txBody>
+      </p:sp>
+    </p:spTree>
+    <p:extLst>
+      <p:ext uri="{BB962C8B-B14F-4D97-AF65-F5344CB8AC3E}">
+        <p14:creationId xmlns:p14="http://schemas.microsoft.com/office/powerpoint/2010/main" val="1024086991"/>
+      </p:ext>
+    </p:extLst>
+  </p:cSld>
+  <p:clrMapOvr>
+    <a:masterClrMapping/>
+  </p:clrMapOvr>
+</p:notes>
+</file>
+
+<file path=ppt/notesSlides/notesSlide11.xml><?xml version="1.0" encoding="utf-8"?>
+<p:notes xmlns:a="http://schemas.openxmlformats.org/drawingml/2006/main" xmlns:r="http://schemas.openxmlformats.org/officeDocument/2006/relationships" xmlns:p="http://schemas.openxmlformats.org/presentationml/2006/main">
+  <p:cSld>
+    <p:spTree>
+      <p:nvGrpSpPr>
+        <p:cNvPr id="1" name=""/>
+        <p:cNvGrpSpPr/>
+        <p:nvPr/>
+      </p:nvGrpSpPr>
+      <p:grpSpPr>
+        <a:xfrm>
+          <a:off x="0" y="0"/>
+          <a:ext cx="0" cy="0"/>
+          <a:chOff x="0" y="0"/>
+          <a:chExt cx="0" cy="0"/>
+        </a:xfrm>
+      </p:grpSpPr>
+      <p:sp>
+        <p:nvSpPr>
+          <p:cNvPr id="2" name="Slide Image Placeholder 1"/>
+          <p:cNvSpPr>
+            <a:spLocks noGrp="1" noRot="1" noChangeAspect="1"/>
+          </p:cNvSpPr>
+          <p:nvPr>
+            <p:ph type="sldImg"/>
+          </p:nvPr>
+        </p:nvSpPr>
+        <p:spPr/>
+      </p:sp>
+      <p:sp>
+        <p:nvSpPr>
+          <p:cNvPr id="3" name="Notes Placeholder 2"/>
+          <p:cNvSpPr>
+            <a:spLocks noGrp="1"/>
+          </p:cNvSpPr>
+          <p:nvPr>
+            <p:ph type="body" idx="1"/>
+          </p:nvPr>
+        </p:nvSpPr>
+        <p:spPr/>
+        <p:txBody>
+          <a:bodyPr/>
+          <a:lstStyle/>
+          <a:p>
+            <a:r>
+              <a:rPr lang="en-US" dirty="0"/>
+              <a:t/>
+            </a:r>
+            <a:endParaRPr lang="en-US" dirty="0"/>
+          </a:p>
+        </p:txBody>
+      </p:sp>
+      <p:sp>
+        <p:nvSpPr>
+          <p:cNvPr id="4" name="Slide Number Placeholder 3"/>
+          <p:cNvSpPr>
+            <a:spLocks noGrp="1"/>
+          </p:cNvSpPr>
+          <p:nvPr>
+            <p:ph type="sldNum" sz="quarter" idx="10"/>
+          </p:nvPr>
+        </p:nvSpPr>
+        <p:spPr/>
+        <p:txBody>
+          <a:bodyPr/>
+          <a:lstStyle/>
+          <a:p>
+            <a:fld id="{F7021451-1387-4CA6-816F-3879F97B5CBC}" type="slidenum">
+              <a:rPr lang="en-US"/>
+              <a:t>11</a:t>
             </a:fld>
             <a:endParaRPr lang="en-US"/>
           </a:p>
@@ -1902,6 +1991,1357 @@
 <file path=ppt/slides/slide10.xml><?xml version="1.0" encoding="utf-8"?>
 <p:sld xmlns:a="http://schemas.openxmlformats.org/drawingml/2006/main" xmlns:r="http://schemas.openxmlformats.org/officeDocument/2006/relationships" xmlns:p="http://schemas.openxmlformats.org/presentationml/2006/main">
   <p:cSld name="Slide 10">
+    <p:bg>
+      <p:bgPr>
+        <a:solidFill>
+          <a:srgbClr val="FFFFFF"/>
+        </a:solidFill>
+      </p:bgPr>
+    </p:bg>
+    <p:spTree>
+      <p:nvGrpSpPr>
+        <p:cNvPr id="1" name=""/>
+        <p:cNvGrpSpPr/>
+        <p:nvPr/>
+      </p:nvGrpSpPr>
+      <p:grpSpPr>
+        <a:xfrm>
+          <a:off x="0" y="0"/>
+          <a:ext cx="0" cy="0"/>
+          <a:chOff x="0" y="0"/>
+          <a:chExt cx="0" cy="0"/>
+        </a:xfrm>
+      </p:grpSpPr>
+      <p:sp>
+        <p:nvSpPr>
+          <p:cNvPr id="2" name="Text 0"/>
+          <p:cNvSpPr/>
+          <p:nvPr/>
+        </p:nvSpPr>
+        <p:spPr>
+          <a:xfrm>
+            <a:off x="457200" y="274320"/>
+            <a:ext cx="10972800" cy="0"/>
+          </a:xfrm>
+          <a:prstGeom prst="rect">
+            <a:avLst/>
+          </a:prstGeom>
+          <a:noFill/>
+          <a:ln/>
+        </p:spPr>
+        <p:txBody>
+          <a:bodyPr wrap="square" rtlCol="0" anchor="ctr"/>
+          <a:lstStyle/>
+          <a:p>
+            <a:pPr indent="0" marL="0">
+              <a:buNone/>
+            </a:pPr>
+            <a:r>
+              <a:rPr lang="en-US" sz="2800" b="1" dirty="0">
+                <a:solidFill>
+                  <a:srgbClr val="1E2761"/>
+                </a:solidFill>
+                <a:latin typeface="Arial Black" pitchFamily="34" charset="0"/>
+                <a:ea typeface="Arial Black" pitchFamily="34" charset="-122"/>
+                <a:cs typeface="Arial Black" pitchFamily="34" charset="-120"/>
+              </a:rPr>
+              <a:t>추진 일정</a:t>
+            </a:r>
+            <a:endParaRPr lang="en-US" sz="2800" dirty="0"/>
+          </a:p>
+        </p:txBody>
+      </p:sp>
+      <p:graphicFrame>
+        <p:nvGraphicFramePr>
+          <p:cNvPr id="11" name="Table 0"/>
+          <p:cNvGraphicFramePr>
+            <a:graphicFrameLocks noGrp="1"/>
+          </p:cNvGraphicFramePr>
+          <p:nvPr>
+            <p:extLst>
+              <p:ext uri="{D42A27DB-BD31-4B8C-83A1-F6EECF244321}">
+                <p14:modId xmlns:p14="http://schemas.microsoft.com/office/powerpoint/2010/main" val="1579011935"/>
+              </p:ext>
+            </p:extLst>
+          </p:nvPr>
+        </p:nvGraphicFramePr>
+        <p:xfrm>
+          <a:off x="457200" y="1097280"/>
+          <a:ext cx="10972800" cy="914400"/>
+        </p:xfrm>
+        <a:graphic>
+          <a:graphicData uri="http://schemas.openxmlformats.org/drawingml/2006/table">
+            <a:tbl>
+              <a:tblPr/>
+              <a:tblGrid>
+                <a:gridCol w="2743200"/>
+                <a:gridCol w="3200400"/>
+                <a:gridCol w="5029200"/>
+              </a:tblGrid>
+              <a:tr h="0">
+                <a:tc>
+                  <a:txBody>
+                    <a:bodyPr/>
+                    <a:lstStyle/>
+                    <a:p>
+                      <a:pPr indent="0" marL="0">
+                        <a:buNone/>
+                      </a:pPr>
+                      <a:r>
+                        <a:rPr lang="en-US" sz="1200" b="1" dirty="0">
+                          <a:solidFill>
+                            <a:srgbClr val="FFFFFF"/>
+                          </a:solidFill>
+                        </a:rPr>
+                        <a:t>기간</a:t>
+                      </a:r>
+                      <a:endParaRPr lang="en-US" sz="1200" dirty="0"/>
+                    </a:p>
+                  </a:txBody>
+                  <a:tcPr marL="152400" marR="152400" marT="101600" marB="101600">
+                    <a:lnL w="6350" cap="flat" cmpd="sng" algn="ctr">
+                      <a:solidFill>
+                        <a:srgbClr val="DDDDDD"/>
+                      </a:solidFill>
+                      <a:prstDash val="solid"/>
+                      <a:round/>
+                      <a:headEnd type="none" w="med" len="med"/>
+                      <a:tailEnd type="none" w="med" len="med"/>
+                    </a:lnL>
+                    <a:lnR w="6350" cap="flat" cmpd="sng" algn="ctr">
+                      <a:solidFill>
+                        <a:srgbClr val="DDDDDD"/>
+                      </a:solidFill>
+                      <a:prstDash val="solid"/>
+                      <a:round/>
+                      <a:headEnd type="none" w="med" len="med"/>
+                      <a:tailEnd type="none" w="med" len="med"/>
+                    </a:lnR>
+                    <a:lnT w="6350" cap="flat" cmpd="sng" algn="ctr">
+                      <a:solidFill>
+                        <a:srgbClr val="DDDDDD"/>
+                      </a:solidFill>
+                      <a:prstDash val="solid"/>
+                      <a:round/>
+                      <a:headEnd type="none" w="med" len="med"/>
+                      <a:tailEnd type="none" w="med" len="med"/>
+                    </a:lnT>
+                    <a:lnB w="6350" cap="flat" cmpd="sng" algn="ctr">
+                      <a:solidFill>
+                        <a:srgbClr val="DDDDDD"/>
+                      </a:solidFill>
+                      <a:prstDash val="solid"/>
+                      <a:round/>
+                      <a:headEnd type="none" w="med" len="med"/>
+                      <a:tailEnd type="none" w="med" len="med"/>
+                    </a:lnB>
+                    <a:solidFill>
+                      <a:srgbClr val="1E2761"/>
+                    </a:solidFill>
+                  </a:tcPr>
+                </a:tc>
+                <a:tc>
+                  <a:txBody>
+                    <a:bodyPr/>
+                    <a:lstStyle/>
+                    <a:p>
+                      <a:pPr indent="0" marL="0">
+                        <a:buNone/>
+                      </a:pPr>
+                      <a:r>
+                        <a:rPr lang="en-US" sz="1200" b="1" dirty="0">
+                          <a:solidFill>
+                            <a:srgbClr val="FFFFFF"/>
+                          </a:solidFill>
+                        </a:rPr>
+                        <a:t>Phase</a:t>
+                      </a:r>
+                      <a:endParaRPr lang="en-US" sz="1200" dirty="0"/>
+                    </a:p>
+                  </a:txBody>
+                  <a:tcPr marL="152400" marR="152400" marT="101600" marB="101600">
+                    <a:lnL w="6350" cap="flat" cmpd="sng" algn="ctr">
+                      <a:solidFill>
+                        <a:srgbClr val="DDDDDD"/>
+                      </a:solidFill>
+                      <a:prstDash val="solid"/>
+                      <a:round/>
+                      <a:headEnd type="none" w="med" len="med"/>
+                      <a:tailEnd type="none" w="med" len="med"/>
+                    </a:lnL>
+                    <a:lnR w="6350" cap="flat" cmpd="sng" algn="ctr">
+                      <a:solidFill>
+                        <a:srgbClr val="DDDDDD"/>
+                      </a:solidFill>
+                      <a:prstDash val="solid"/>
+                      <a:round/>
+                      <a:headEnd type="none" w="med" len="med"/>
+                      <a:tailEnd type="none" w="med" len="med"/>
+                    </a:lnR>
+                    <a:lnT w="6350" cap="flat" cmpd="sng" algn="ctr">
+                      <a:solidFill>
+                        <a:srgbClr val="DDDDDD"/>
+                      </a:solidFill>
+                      <a:prstDash val="solid"/>
+                      <a:round/>
+                      <a:headEnd type="none" w="med" len="med"/>
+                      <a:tailEnd type="none" w="med" len="med"/>
+                    </a:lnT>
+                    <a:lnB w="6350" cap="flat" cmpd="sng" algn="ctr">
+                      <a:solidFill>
+                        <a:srgbClr val="DDDDDD"/>
+                      </a:solidFill>
+                      <a:prstDash val="solid"/>
+                      <a:round/>
+                      <a:headEnd type="none" w="med" len="med"/>
+                      <a:tailEnd type="none" w="med" len="med"/>
+                    </a:lnB>
+                    <a:solidFill>
+                      <a:srgbClr val="1E2761"/>
+                    </a:solidFill>
+                  </a:tcPr>
+                </a:tc>
+                <a:tc>
+                  <a:txBody>
+                    <a:bodyPr/>
+                    <a:lstStyle/>
+                    <a:p>
+                      <a:pPr indent="0" marL="0">
+                        <a:buNone/>
+                      </a:pPr>
+                      <a:r>
+                        <a:rPr lang="en-US" sz="1200" b="1" dirty="0">
+                          <a:solidFill>
+                            <a:srgbClr val="FFFFFF"/>
+                          </a:solidFill>
+                        </a:rPr>
+                        <a:t>핵심 마일스톤</a:t>
+                      </a:r>
+                      <a:endParaRPr lang="en-US" sz="1200" dirty="0"/>
+                    </a:p>
+                  </a:txBody>
+                  <a:tcPr marL="152400" marR="152400" marT="101600" marB="101600">
+                    <a:lnL w="6350" cap="flat" cmpd="sng" algn="ctr">
+                      <a:solidFill>
+                        <a:srgbClr val="DDDDDD"/>
+                      </a:solidFill>
+                      <a:prstDash val="solid"/>
+                      <a:round/>
+                      <a:headEnd type="none" w="med" len="med"/>
+                      <a:tailEnd type="none" w="med" len="med"/>
+                    </a:lnL>
+                    <a:lnR w="6350" cap="flat" cmpd="sng" algn="ctr">
+                      <a:solidFill>
+                        <a:srgbClr val="DDDDDD"/>
+                      </a:solidFill>
+                      <a:prstDash val="solid"/>
+                      <a:round/>
+                      <a:headEnd type="none" w="med" len="med"/>
+                      <a:tailEnd type="none" w="med" len="med"/>
+                    </a:lnR>
+                    <a:lnT w="6350" cap="flat" cmpd="sng" algn="ctr">
+                      <a:solidFill>
+                        <a:srgbClr val="DDDDDD"/>
+                      </a:solidFill>
+                      <a:prstDash val="solid"/>
+                      <a:round/>
+                      <a:headEnd type="none" w="med" len="med"/>
+                      <a:tailEnd type="none" w="med" len="med"/>
+                    </a:lnT>
+                    <a:lnB w="6350" cap="flat" cmpd="sng" algn="ctr">
+                      <a:solidFill>
+                        <a:srgbClr val="DDDDDD"/>
+                      </a:solidFill>
+                      <a:prstDash val="solid"/>
+                      <a:round/>
+                      <a:headEnd type="none" w="med" len="med"/>
+                      <a:tailEnd type="none" w="med" len="med"/>
+                    </a:lnB>
+                    <a:solidFill>
+                      <a:srgbClr val="1E2761"/>
+                    </a:solidFill>
+                  </a:tcPr>
+                </a:tc>
+              </a:tr>
+              <a:tr h="0">
+                <a:tc>
+                  <a:txBody>
+                    <a:bodyPr/>
+                    <a:lstStyle/>
+                    <a:p>
+                      <a:pPr indent="0" marL="0">
+                        <a:buNone/>
+                      </a:pPr>
+                      <a:r>
+                        <a:rPr lang="en-US" sz="1200" dirty="0">
+                          <a:solidFill>
+                            <a:srgbClr val="1A1A2E"/>
+                          </a:solidFill>
+                        </a:rPr>
+                        <a:t>2026 Q2</a:t>
+                      </a:r>
+                      <a:endParaRPr lang="en-US" sz="1200" dirty="0"/>
+                    </a:p>
+                  </a:txBody>
+                  <a:tcPr marL="152400" marR="152400" marT="101600" marB="101600">
+                    <a:lnL w="6350" cap="flat" cmpd="sng" algn="ctr">
+                      <a:solidFill>
+                        <a:srgbClr val="DDDDDD"/>
+                      </a:solidFill>
+                      <a:prstDash val="solid"/>
+                      <a:round/>
+                      <a:headEnd type="none" w="med" len="med"/>
+                      <a:tailEnd type="none" w="med" len="med"/>
+                    </a:lnL>
+                    <a:lnR w="6350" cap="flat" cmpd="sng" algn="ctr">
+                      <a:solidFill>
+                        <a:srgbClr val="DDDDDD"/>
+                      </a:solidFill>
+                      <a:prstDash val="solid"/>
+                      <a:round/>
+                      <a:headEnd type="none" w="med" len="med"/>
+                      <a:tailEnd type="none" w="med" len="med"/>
+                    </a:lnR>
+                    <a:lnT w="6350" cap="flat" cmpd="sng" algn="ctr">
+                      <a:solidFill>
+                        <a:srgbClr val="DDDDDD"/>
+                      </a:solidFill>
+                      <a:prstDash val="solid"/>
+                      <a:round/>
+                      <a:headEnd type="none" w="med" len="med"/>
+                      <a:tailEnd type="none" w="med" len="med"/>
+                    </a:lnT>
+                    <a:lnB w="6350" cap="flat" cmpd="sng" algn="ctr">
+                      <a:solidFill>
+                        <a:srgbClr val="DDDDDD"/>
+                      </a:solidFill>
+                      <a:prstDash val="solid"/>
+                      <a:round/>
+                      <a:headEnd type="none" w="med" len="med"/>
+                      <a:tailEnd type="none" w="med" len="med"/>
+                    </a:lnB>
+                    <a:solidFill>
+                      <a:srgbClr val="F8F9FA"/>
+                    </a:solidFill>
+                  </a:tcPr>
+                </a:tc>
+                <a:tc>
+                  <a:txBody>
+                    <a:bodyPr/>
+                    <a:lstStyle/>
+                    <a:p>
+                      <a:pPr indent="0" marL="0">
+                        <a:buNone/>
+                      </a:pPr>
+                      <a:r>
+                        <a:rPr lang="en-US" sz="1200" dirty="0">
+                          <a:solidFill>
+                            <a:srgbClr val="1A1A2E"/>
+                          </a:solidFill>
+                        </a:rPr>
+                        <a:t>Pre-Dev + Phase 1 시작</a:t>
+                      </a:r>
+                      <a:endParaRPr lang="en-US" sz="1200" dirty="0"/>
+                    </a:p>
+                  </a:txBody>
+                  <a:tcPr marL="152400" marR="152400" marT="101600" marB="101600">
+                    <a:lnL w="6350" cap="flat" cmpd="sng" algn="ctr">
+                      <a:solidFill>
+                        <a:srgbClr val="DDDDDD"/>
+                      </a:solidFill>
+                      <a:prstDash val="solid"/>
+                      <a:round/>
+                      <a:headEnd type="none" w="med" len="med"/>
+                      <a:tailEnd type="none" w="med" len="med"/>
+                    </a:lnL>
+                    <a:lnR w="6350" cap="flat" cmpd="sng" algn="ctr">
+                      <a:solidFill>
+                        <a:srgbClr val="DDDDDD"/>
+                      </a:solidFill>
+                      <a:prstDash val="solid"/>
+                      <a:round/>
+                      <a:headEnd type="none" w="med" len="med"/>
+                      <a:tailEnd type="none" w="med" len="med"/>
+                    </a:lnR>
+                    <a:lnT w="6350" cap="flat" cmpd="sng" algn="ctr">
+                      <a:solidFill>
+                        <a:srgbClr val="DDDDDD"/>
+                      </a:solidFill>
+                      <a:prstDash val="solid"/>
+                      <a:round/>
+                      <a:headEnd type="none" w="med" len="med"/>
+                      <a:tailEnd type="none" w="med" len="med"/>
+                    </a:lnT>
+                    <a:lnB w="6350" cap="flat" cmpd="sng" algn="ctr">
+                      <a:solidFill>
+                        <a:srgbClr val="DDDDDD"/>
+                      </a:solidFill>
+                      <a:prstDash val="solid"/>
+                      <a:round/>
+                      <a:headEnd type="none" w="med" len="med"/>
+                      <a:tailEnd type="none" w="med" len="med"/>
+                    </a:lnB>
+                    <a:solidFill>
+                      <a:srgbClr val="F8F9FA"/>
+                    </a:solidFill>
+                  </a:tcPr>
+                </a:tc>
+                <a:tc>
+                  <a:txBody>
+                    <a:bodyPr/>
+                    <a:lstStyle/>
+                    <a:p>
+                      <a:pPr indent="0" marL="0">
+                        <a:buNone/>
+                      </a:pPr>
+                      <a:r>
+                        <a:rPr lang="en-US" sz="1200" dirty="0">
+                          <a:solidFill>
+                            <a:srgbClr val="1A1A2E"/>
+                          </a:solidFill>
+                        </a:rPr>
+                        <a:t>BRD/PRD 완료, 개발 착수</a:t>
+                      </a:r>
+                      <a:endParaRPr lang="en-US" sz="1200" dirty="0"/>
+                    </a:p>
+                  </a:txBody>
+                  <a:tcPr marL="152400" marR="152400" marT="101600" marB="101600">
+                    <a:lnL w="6350" cap="flat" cmpd="sng" algn="ctr">
+                      <a:solidFill>
+                        <a:srgbClr val="DDDDDD"/>
+                      </a:solidFill>
+                      <a:prstDash val="solid"/>
+                      <a:round/>
+                      <a:headEnd type="none" w="med" len="med"/>
+                      <a:tailEnd type="none" w="med" len="med"/>
+                    </a:lnL>
+                    <a:lnR w="6350" cap="flat" cmpd="sng" algn="ctr">
+                      <a:solidFill>
+                        <a:srgbClr val="DDDDDD"/>
+                      </a:solidFill>
+                      <a:prstDash val="solid"/>
+                      <a:round/>
+                      <a:headEnd type="none" w="med" len="med"/>
+                      <a:tailEnd type="none" w="med" len="med"/>
+                    </a:lnR>
+                    <a:lnT w="6350" cap="flat" cmpd="sng" algn="ctr">
+                      <a:solidFill>
+                        <a:srgbClr val="DDDDDD"/>
+                      </a:solidFill>
+                      <a:prstDash val="solid"/>
+                      <a:round/>
+                      <a:headEnd type="none" w="med" len="med"/>
+                      <a:tailEnd type="none" w="med" len="med"/>
+                    </a:lnT>
+                    <a:lnB w="6350" cap="flat" cmpd="sng" algn="ctr">
+                      <a:solidFill>
+                        <a:srgbClr val="DDDDDD"/>
+                      </a:solidFill>
+                      <a:prstDash val="solid"/>
+                      <a:round/>
+                      <a:headEnd type="none" w="med" len="med"/>
+                      <a:tailEnd type="none" w="med" len="med"/>
+                    </a:lnB>
+                    <a:solidFill>
+                      <a:srgbClr val="F8F9FA"/>
+                    </a:solidFill>
+                  </a:tcPr>
+                </a:tc>
+              </a:tr>
+              <a:tr h="0">
+                <a:tc>
+                  <a:txBody>
+                    <a:bodyPr/>
+                    <a:lstStyle/>
+                    <a:p>
+                      <a:pPr indent="0" marL="0">
+                        <a:buNone/>
+                      </a:pPr>
+                      <a:r>
+                        <a:rPr lang="en-US" sz="1200" dirty="0">
+                          <a:solidFill>
+                            <a:srgbClr val="1A1A2E"/>
+                          </a:solidFill>
+                        </a:rPr>
+                        <a:t>2026 Q3</a:t>
+                      </a:r>
+                      <a:endParaRPr lang="en-US" sz="1200" dirty="0"/>
+                    </a:p>
+                  </a:txBody>
+                  <a:tcPr marL="152400" marR="152400" marT="101600" marB="101600">
+                    <a:lnL w="6350" cap="flat" cmpd="sng" algn="ctr">
+                      <a:solidFill>
+                        <a:srgbClr val="DDDDDD"/>
+                      </a:solidFill>
+                      <a:prstDash val="solid"/>
+                      <a:round/>
+                      <a:headEnd type="none" w="med" len="med"/>
+                      <a:tailEnd type="none" w="med" len="med"/>
+                    </a:lnL>
+                    <a:lnR w="6350" cap="flat" cmpd="sng" algn="ctr">
+                      <a:solidFill>
+                        <a:srgbClr val="DDDDDD"/>
+                      </a:solidFill>
+                      <a:prstDash val="solid"/>
+                      <a:round/>
+                      <a:headEnd type="none" w="med" len="med"/>
+                      <a:tailEnd type="none" w="med" len="med"/>
+                    </a:lnR>
+                    <a:lnT w="6350" cap="flat" cmpd="sng" algn="ctr">
+                      <a:solidFill>
+                        <a:srgbClr val="DDDDDD"/>
+                      </a:solidFill>
+                      <a:prstDash val="solid"/>
+                      <a:round/>
+                      <a:headEnd type="none" w="med" len="med"/>
+                      <a:tailEnd type="none" w="med" len="med"/>
+                    </a:lnT>
+                    <a:lnB w="6350" cap="flat" cmpd="sng" algn="ctr">
+                      <a:solidFill>
+                        <a:srgbClr val="DDDDDD"/>
+                      </a:solidFill>
+                      <a:prstDash val="solid"/>
+                      <a:round/>
+                      <a:headEnd type="none" w="med" len="med"/>
+                      <a:tailEnd type="none" w="med" len="med"/>
+                    </a:lnB>
+                    <a:solidFill>
+                      <a:srgbClr val="F8F9FA"/>
+                    </a:solidFill>
+                  </a:tcPr>
+                </a:tc>
+                <a:tc>
+                  <a:txBody>
+                    <a:bodyPr/>
+                    <a:lstStyle/>
+                    <a:p>
+                      <a:pPr indent="0" marL="0">
+                        <a:buNone/>
+                      </a:pPr>
+                      <a:r>
+                        <a:rPr lang="en-US" sz="1200" dirty="0">
+                          <a:solidFill>
+                            <a:srgbClr val="1A1A2E"/>
+                          </a:solidFill>
+                        </a:rPr>
+                        <a:t>Phase 1 완료 + 출시</a:t>
+                      </a:r>
+                      <a:endParaRPr lang="en-US" sz="1200" dirty="0"/>
+                    </a:p>
+                  </a:txBody>
+                  <a:tcPr marL="152400" marR="152400" marT="101600" marB="101600">
+                    <a:lnL w="6350" cap="flat" cmpd="sng" algn="ctr">
+                      <a:solidFill>
+                        <a:srgbClr val="DDDDDD"/>
+                      </a:solidFill>
+                      <a:prstDash val="solid"/>
+                      <a:round/>
+                      <a:headEnd type="none" w="med" len="med"/>
+                      <a:tailEnd type="none" w="med" len="med"/>
+                    </a:lnL>
+                    <a:lnR w="6350" cap="flat" cmpd="sng" algn="ctr">
+                      <a:solidFill>
+                        <a:srgbClr val="DDDDDD"/>
+                      </a:solidFill>
+                      <a:prstDash val="solid"/>
+                      <a:round/>
+                      <a:headEnd type="none" w="med" len="med"/>
+                      <a:tailEnd type="none" w="med" len="med"/>
+                    </a:lnR>
+                    <a:lnT w="6350" cap="flat" cmpd="sng" algn="ctr">
+                      <a:solidFill>
+                        <a:srgbClr val="DDDDDD"/>
+                      </a:solidFill>
+                      <a:prstDash val="solid"/>
+                      <a:round/>
+                      <a:headEnd type="none" w="med" len="med"/>
+                      <a:tailEnd type="none" w="med" len="med"/>
+                    </a:lnT>
+                    <a:lnB w="6350" cap="flat" cmpd="sng" algn="ctr">
+                      <a:solidFill>
+                        <a:srgbClr val="DDDDDD"/>
+                      </a:solidFill>
+                      <a:prstDash val="solid"/>
+                      <a:round/>
+                      <a:headEnd type="none" w="med" len="med"/>
+                      <a:tailEnd type="none" w="med" len="med"/>
+                    </a:lnB>
+                    <a:solidFill>
+                      <a:srgbClr val="F8F9FA"/>
+                    </a:solidFill>
+                  </a:tcPr>
+                </a:tc>
+                <a:tc>
+                  <a:txBody>
+                    <a:bodyPr/>
+                    <a:lstStyle/>
+                    <a:p>
+                      <a:pPr indent="0" marL="0">
+                        <a:buNone/>
+                      </a:pPr>
+                      <a:r>
+                        <a:rPr lang="en-US" sz="1200" dirty="0">
+                          <a:solidFill>
+                            <a:srgbClr val="1A1A2E"/>
+                          </a:solidFill>
+                        </a:rPr>
+                        <a:t>앱스토어 출시, MAU 10,000 목표</a:t>
+                      </a:r>
+                      <a:endParaRPr lang="en-US" sz="1200" dirty="0"/>
+                    </a:p>
+                  </a:txBody>
+                  <a:tcPr marL="152400" marR="152400" marT="101600" marB="101600">
+                    <a:lnL w="6350" cap="flat" cmpd="sng" algn="ctr">
+                      <a:solidFill>
+                        <a:srgbClr val="DDDDDD"/>
+                      </a:solidFill>
+                      <a:prstDash val="solid"/>
+                      <a:round/>
+                      <a:headEnd type="none" w="med" len="med"/>
+                      <a:tailEnd type="none" w="med" len="med"/>
+                    </a:lnL>
+                    <a:lnR w="6350" cap="flat" cmpd="sng" algn="ctr">
+                      <a:solidFill>
+                        <a:srgbClr val="DDDDDD"/>
+                      </a:solidFill>
+                      <a:prstDash val="solid"/>
+                      <a:round/>
+                      <a:headEnd type="none" w="med" len="med"/>
+                      <a:tailEnd type="none" w="med" len="med"/>
+                    </a:lnR>
+                    <a:lnT w="6350" cap="flat" cmpd="sng" algn="ctr">
+                      <a:solidFill>
+                        <a:srgbClr val="DDDDDD"/>
+                      </a:solidFill>
+                      <a:prstDash val="solid"/>
+                      <a:round/>
+                      <a:headEnd type="none" w="med" len="med"/>
+                      <a:tailEnd type="none" w="med" len="med"/>
+                    </a:lnT>
+                    <a:lnB w="6350" cap="flat" cmpd="sng" algn="ctr">
+                      <a:solidFill>
+                        <a:srgbClr val="DDDDDD"/>
+                      </a:solidFill>
+                      <a:prstDash val="solid"/>
+                      <a:round/>
+                      <a:headEnd type="none" w="med" len="med"/>
+                      <a:tailEnd type="none" w="med" len="med"/>
+                    </a:lnB>
+                    <a:solidFill>
+                      <a:srgbClr val="F8F9FA"/>
+                    </a:solidFill>
+                  </a:tcPr>
+                </a:tc>
+              </a:tr>
+              <a:tr h="0">
+                <a:tc>
+                  <a:txBody>
+                    <a:bodyPr/>
+                    <a:lstStyle/>
+                    <a:p>
+                      <a:pPr indent="0" marL="0">
+                        <a:buNone/>
+                      </a:pPr>
+                      <a:r>
+                        <a:rPr lang="en-US" sz="1200" dirty="0">
+                          <a:solidFill>
+                            <a:srgbClr val="1A1A2E"/>
+                          </a:solidFill>
+                        </a:rPr>
+                        <a:t>2026 Q4~2027 Q1</a:t>
+                      </a:r>
+                      <a:endParaRPr lang="en-US" sz="1200" dirty="0"/>
+                    </a:p>
+                  </a:txBody>
+                  <a:tcPr marL="152400" marR="152400" marT="101600" marB="101600">
+                    <a:lnL w="6350" cap="flat" cmpd="sng" algn="ctr">
+                      <a:solidFill>
+                        <a:srgbClr val="DDDDDD"/>
+                      </a:solidFill>
+                      <a:prstDash val="solid"/>
+                      <a:round/>
+                      <a:headEnd type="none" w="med" len="med"/>
+                      <a:tailEnd type="none" w="med" len="med"/>
+                    </a:lnL>
+                    <a:lnR w="6350" cap="flat" cmpd="sng" algn="ctr">
+                      <a:solidFill>
+                        <a:srgbClr val="DDDDDD"/>
+                      </a:solidFill>
+                      <a:prstDash val="solid"/>
+                      <a:round/>
+                      <a:headEnd type="none" w="med" len="med"/>
+                      <a:tailEnd type="none" w="med" len="med"/>
+                    </a:lnR>
+                    <a:lnT w="6350" cap="flat" cmpd="sng" algn="ctr">
+                      <a:solidFill>
+                        <a:srgbClr val="DDDDDD"/>
+                      </a:solidFill>
+                      <a:prstDash val="solid"/>
+                      <a:round/>
+                      <a:headEnd type="none" w="med" len="med"/>
+                      <a:tailEnd type="none" w="med" len="med"/>
+                    </a:lnT>
+                    <a:lnB w="6350" cap="flat" cmpd="sng" algn="ctr">
+                      <a:solidFill>
+                        <a:srgbClr val="DDDDDD"/>
+                      </a:solidFill>
+                      <a:prstDash val="solid"/>
+                      <a:round/>
+                      <a:headEnd type="none" w="med" len="med"/>
+                      <a:tailEnd type="none" w="med" len="med"/>
+                    </a:lnB>
+                    <a:solidFill>
+                      <a:srgbClr val="F8F9FA"/>
+                    </a:solidFill>
+                  </a:tcPr>
+                </a:tc>
+                <a:tc>
+                  <a:txBody>
+                    <a:bodyPr/>
+                    <a:lstStyle/>
+                    <a:p>
+                      <a:pPr indent="0" marL="0">
+                        <a:buNone/>
+                      </a:pPr>
+                      <a:r>
+                        <a:rPr lang="en-US" sz="1200" dirty="0">
+                          <a:solidFill>
+                            <a:srgbClr val="1A1A2E"/>
+                          </a:solidFill>
+                        </a:rPr>
+                        <a:t>Phase 2 멀티스포츠</a:t>
+                      </a:r>
+                      <a:endParaRPr lang="en-US" sz="1200" dirty="0"/>
+                    </a:p>
+                  </a:txBody>
+                  <a:tcPr marL="152400" marR="152400" marT="101600" marB="101600">
+                    <a:lnL w="6350" cap="flat" cmpd="sng" algn="ctr">
+                      <a:solidFill>
+                        <a:srgbClr val="DDDDDD"/>
+                      </a:solidFill>
+                      <a:prstDash val="solid"/>
+                      <a:round/>
+                      <a:headEnd type="none" w="med" len="med"/>
+                      <a:tailEnd type="none" w="med" len="med"/>
+                    </a:lnL>
+                    <a:lnR w="6350" cap="flat" cmpd="sng" algn="ctr">
+                      <a:solidFill>
+                        <a:srgbClr val="DDDDDD"/>
+                      </a:solidFill>
+                      <a:prstDash val="solid"/>
+                      <a:round/>
+                      <a:headEnd type="none" w="med" len="med"/>
+                      <a:tailEnd type="none" w="med" len="med"/>
+                    </a:lnR>
+                    <a:lnT w="6350" cap="flat" cmpd="sng" algn="ctr">
+                      <a:solidFill>
+                        <a:srgbClr val="DDDDDD"/>
+                      </a:solidFill>
+                      <a:prstDash val="solid"/>
+                      <a:round/>
+                      <a:headEnd type="none" w="med" len="med"/>
+                      <a:tailEnd type="none" w="med" len="med"/>
+                    </a:lnT>
+                    <a:lnB w="6350" cap="flat" cmpd="sng" algn="ctr">
+                      <a:solidFill>
+                        <a:srgbClr val="DDDDDD"/>
+                      </a:solidFill>
+                      <a:prstDash val="solid"/>
+                      <a:round/>
+                      <a:headEnd type="none" w="med" len="med"/>
+                      <a:tailEnd type="none" w="med" len="med"/>
+                    </a:lnB>
+                    <a:solidFill>
+                      <a:srgbClr val="F8F9FA"/>
+                    </a:solidFill>
+                  </a:tcPr>
+                </a:tc>
+                <a:tc>
+                  <a:txBody>
+                    <a:bodyPr/>
+                    <a:lstStyle/>
+                    <a:p>
+                      <a:pPr indent="0" marL="0">
+                        <a:buNone/>
+                      </a:pPr>
+                      <a:r>
+                        <a:rPr lang="en-US" sz="1200" dirty="0">
+                          <a:solidFill>
+                            <a:srgbClr val="1A1A2E"/>
+                          </a:solidFill>
+                        </a:rPr>
+                        <a:t>관광공사 MOU, 파크런 시작</a:t>
+                      </a:r>
+                      <a:endParaRPr lang="en-US" sz="1200" dirty="0"/>
+                    </a:p>
+                  </a:txBody>
+                  <a:tcPr marL="152400" marR="152400" marT="101600" marB="101600">
+                    <a:lnL w="6350" cap="flat" cmpd="sng" algn="ctr">
+                      <a:solidFill>
+                        <a:srgbClr val="DDDDDD"/>
+                      </a:solidFill>
+                      <a:prstDash val="solid"/>
+                      <a:round/>
+                      <a:headEnd type="none" w="med" len="med"/>
+                      <a:tailEnd type="none" w="med" len="med"/>
+                    </a:lnL>
+                    <a:lnR w="6350" cap="flat" cmpd="sng" algn="ctr">
+                      <a:solidFill>
+                        <a:srgbClr val="DDDDDD"/>
+                      </a:solidFill>
+                      <a:prstDash val="solid"/>
+                      <a:round/>
+                      <a:headEnd type="none" w="med" len="med"/>
+                      <a:tailEnd type="none" w="med" len="med"/>
+                    </a:lnR>
+                    <a:lnT w="6350" cap="flat" cmpd="sng" algn="ctr">
+                      <a:solidFill>
+                        <a:srgbClr val="DDDDDD"/>
+                      </a:solidFill>
+                      <a:prstDash val="solid"/>
+                      <a:round/>
+                      <a:headEnd type="none" w="med" len="med"/>
+                      <a:tailEnd type="none" w="med" len="med"/>
+                    </a:lnT>
+                    <a:lnB w="6350" cap="flat" cmpd="sng" algn="ctr">
+                      <a:solidFill>
+                        <a:srgbClr val="DDDDDD"/>
+                      </a:solidFill>
+                      <a:prstDash val="solid"/>
+                      <a:round/>
+                      <a:headEnd type="none" w="med" len="med"/>
+                      <a:tailEnd type="none" w="med" len="med"/>
+                    </a:lnB>
+                    <a:solidFill>
+                      <a:srgbClr val="F8F9FA"/>
+                    </a:solidFill>
+                  </a:tcPr>
+                </a:tc>
+              </a:tr>
+              <a:tr h="0">
+                <a:tc>
+                  <a:txBody>
+                    <a:bodyPr/>
+                    <a:lstStyle/>
+                    <a:p>
+                      <a:pPr indent="0" marL="0">
+                        <a:buNone/>
+                      </a:pPr>
+                      <a:r>
+                        <a:rPr lang="en-US" sz="1200" dirty="0">
+                          <a:solidFill>
+                            <a:srgbClr val="1A1A2E"/>
+                          </a:solidFill>
+                        </a:rPr>
+                        <a:t>2027 Q1~Q3</a:t>
+                      </a:r>
+                      <a:endParaRPr lang="en-US" sz="1200" dirty="0"/>
+                    </a:p>
+                  </a:txBody>
+                  <a:tcPr marL="152400" marR="152400" marT="101600" marB="101600">
+                    <a:lnL w="6350" cap="flat" cmpd="sng" algn="ctr">
+                      <a:solidFill>
+                        <a:srgbClr val="DDDDDD"/>
+                      </a:solidFill>
+                      <a:prstDash val="solid"/>
+                      <a:round/>
+                      <a:headEnd type="none" w="med" len="med"/>
+                      <a:tailEnd type="none" w="med" len="med"/>
+                    </a:lnL>
+                    <a:lnR w="6350" cap="flat" cmpd="sng" algn="ctr">
+                      <a:solidFill>
+                        <a:srgbClr val="DDDDDD"/>
+                      </a:solidFill>
+                      <a:prstDash val="solid"/>
+                      <a:round/>
+                      <a:headEnd type="none" w="med" len="med"/>
+                      <a:tailEnd type="none" w="med" len="med"/>
+                    </a:lnR>
+                    <a:lnT w="6350" cap="flat" cmpd="sng" algn="ctr">
+                      <a:solidFill>
+                        <a:srgbClr val="DDDDDD"/>
+                      </a:solidFill>
+                      <a:prstDash val="solid"/>
+                      <a:round/>
+                      <a:headEnd type="none" w="med" len="med"/>
+                      <a:tailEnd type="none" w="med" len="med"/>
+                    </a:lnT>
+                    <a:lnB w="6350" cap="flat" cmpd="sng" algn="ctr">
+                      <a:solidFill>
+                        <a:srgbClr val="DDDDDD"/>
+                      </a:solidFill>
+                      <a:prstDash val="solid"/>
+                      <a:round/>
+                      <a:headEnd type="none" w="med" len="med"/>
+                      <a:tailEnd type="none" w="med" len="med"/>
+                    </a:lnB>
+                    <a:solidFill>
+                      <a:srgbClr val="F8F9FA"/>
+                    </a:solidFill>
+                  </a:tcPr>
+                </a:tc>
+                <a:tc>
+                  <a:txBody>
+                    <a:bodyPr/>
+                    <a:lstStyle/>
+                    <a:p>
+                      <a:pPr indent="0" marL="0">
+                        <a:buNone/>
+                      </a:pPr>
+                      <a:r>
+                        <a:rPr lang="en-US" sz="1200" dirty="0">
+                          <a:solidFill>
+                            <a:srgbClr val="1A1A2E"/>
+                          </a:solidFill>
+                        </a:rPr>
+                        <a:t>Phase 3 커머스</a:t>
+                      </a:r>
+                      <a:endParaRPr lang="en-US" sz="1200" dirty="0"/>
+                    </a:p>
+                  </a:txBody>
+                  <a:tcPr marL="152400" marR="152400" marT="101600" marB="101600">
+                    <a:lnL w="6350" cap="flat" cmpd="sng" algn="ctr">
+                      <a:solidFill>
+                        <a:srgbClr val="DDDDDD"/>
+                      </a:solidFill>
+                      <a:prstDash val="solid"/>
+                      <a:round/>
+                      <a:headEnd type="none" w="med" len="med"/>
+                      <a:tailEnd type="none" w="med" len="med"/>
+                    </a:lnL>
+                    <a:lnR w="6350" cap="flat" cmpd="sng" algn="ctr">
+                      <a:solidFill>
+                        <a:srgbClr val="DDDDDD"/>
+                      </a:solidFill>
+                      <a:prstDash val="solid"/>
+                      <a:round/>
+                      <a:headEnd type="none" w="med" len="med"/>
+                      <a:tailEnd type="none" w="med" len="med"/>
+                    </a:lnR>
+                    <a:lnT w="6350" cap="flat" cmpd="sng" algn="ctr">
+                      <a:solidFill>
+                        <a:srgbClr val="DDDDDD"/>
+                      </a:solidFill>
+                      <a:prstDash val="solid"/>
+                      <a:round/>
+                      <a:headEnd type="none" w="med" len="med"/>
+                      <a:tailEnd type="none" w="med" len="med"/>
+                    </a:lnT>
+                    <a:lnB w="6350" cap="flat" cmpd="sng" algn="ctr">
+                      <a:solidFill>
+                        <a:srgbClr val="DDDDDD"/>
+                      </a:solidFill>
+                      <a:prstDash val="solid"/>
+                      <a:round/>
+                      <a:headEnd type="none" w="med" len="med"/>
+                      <a:tailEnd type="none" w="med" len="med"/>
+                    </a:lnB>
+                    <a:solidFill>
+                      <a:srgbClr val="F8F9FA"/>
+                    </a:solidFill>
+                  </a:tcPr>
+                </a:tc>
+                <a:tc>
+                  <a:txBody>
+                    <a:bodyPr/>
+                    <a:lstStyle/>
+                    <a:p>
+                      <a:pPr indent="0" marL="0">
+                        <a:buNone/>
+                      </a:pPr>
+                      <a:r>
+                        <a:rPr lang="en-US" sz="1200" dirty="0">
+                          <a:solidFill>
+                            <a:srgbClr val="1A1A2E"/>
+                          </a:solidFill>
+                        </a:rPr>
+                        <a:t>일반샵+깜깜이방, 매출 발생</a:t>
+                      </a:r>
+                      <a:endParaRPr lang="en-US" sz="1200" dirty="0"/>
+                    </a:p>
+                  </a:txBody>
+                  <a:tcPr marL="152400" marR="152400" marT="101600" marB="101600">
+                    <a:lnL w="6350" cap="flat" cmpd="sng" algn="ctr">
+                      <a:solidFill>
+                        <a:srgbClr val="DDDDDD"/>
+                      </a:solidFill>
+                      <a:prstDash val="solid"/>
+                      <a:round/>
+                      <a:headEnd type="none" w="med" len="med"/>
+                      <a:tailEnd type="none" w="med" len="med"/>
+                    </a:lnL>
+                    <a:lnR w="6350" cap="flat" cmpd="sng" algn="ctr">
+                      <a:solidFill>
+                        <a:srgbClr val="DDDDDD"/>
+                      </a:solidFill>
+                      <a:prstDash val="solid"/>
+                      <a:round/>
+                      <a:headEnd type="none" w="med" len="med"/>
+                      <a:tailEnd type="none" w="med" len="med"/>
+                    </a:lnR>
+                    <a:lnT w="6350" cap="flat" cmpd="sng" algn="ctr">
+                      <a:solidFill>
+                        <a:srgbClr val="DDDDDD"/>
+                      </a:solidFill>
+                      <a:prstDash val="solid"/>
+                      <a:round/>
+                      <a:headEnd type="none" w="med" len="med"/>
+                      <a:tailEnd type="none" w="med" len="med"/>
+                    </a:lnT>
+                    <a:lnB w="6350" cap="flat" cmpd="sng" algn="ctr">
+                      <a:solidFill>
+                        <a:srgbClr val="DDDDDD"/>
+                      </a:solidFill>
+                      <a:prstDash val="solid"/>
+                      <a:round/>
+                      <a:headEnd type="none" w="med" len="med"/>
+                      <a:tailEnd type="none" w="med" len="med"/>
+                    </a:lnB>
+                    <a:solidFill>
+                      <a:srgbClr val="F8F9FA"/>
+                    </a:solidFill>
+                  </a:tcPr>
+                </a:tc>
+              </a:tr>
+              <a:tr h="0">
+                <a:tc>
+                  <a:txBody>
+                    <a:bodyPr/>
+                    <a:lstStyle/>
+                    <a:p>
+                      <a:pPr indent="0" marL="0">
+                        <a:buNone/>
+                      </a:pPr>
+                      <a:r>
+                        <a:rPr lang="en-US" sz="1200" dirty="0">
+                          <a:solidFill>
+                            <a:srgbClr val="1A1A2E"/>
+                          </a:solidFill>
+                        </a:rPr>
+                        <a:t>2027 Q3~2028 Q1</a:t>
+                      </a:r>
+                      <a:endParaRPr lang="en-US" sz="1200" dirty="0"/>
+                    </a:p>
+                  </a:txBody>
+                  <a:tcPr marL="152400" marR="152400" marT="101600" marB="101600">
+                    <a:lnL w="6350" cap="flat" cmpd="sng" algn="ctr">
+                      <a:solidFill>
+                        <a:srgbClr val="DDDDDD"/>
+                      </a:solidFill>
+                      <a:prstDash val="solid"/>
+                      <a:round/>
+                      <a:headEnd type="none" w="med" len="med"/>
+                      <a:tailEnd type="none" w="med" len="med"/>
+                    </a:lnL>
+                    <a:lnR w="6350" cap="flat" cmpd="sng" algn="ctr">
+                      <a:solidFill>
+                        <a:srgbClr val="DDDDDD"/>
+                      </a:solidFill>
+                      <a:prstDash val="solid"/>
+                      <a:round/>
+                      <a:headEnd type="none" w="med" len="med"/>
+                      <a:tailEnd type="none" w="med" len="med"/>
+                    </a:lnR>
+                    <a:lnT w="6350" cap="flat" cmpd="sng" algn="ctr">
+                      <a:solidFill>
+                        <a:srgbClr val="DDDDDD"/>
+                      </a:solidFill>
+                      <a:prstDash val="solid"/>
+                      <a:round/>
+                      <a:headEnd type="none" w="med" len="med"/>
+                      <a:tailEnd type="none" w="med" len="med"/>
+                    </a:lnT>
+                    <a:lnB w="6350" cap="flat" cmpd="sng" algn="ctr">
+                      <a:solidFill>
+                        <a:srgbClr val="DDDDDD"/>
+                      </a:solidFill>
+                      <a:prstDash val="solid"/>
+                      <a:round/>
+                      <a:headEnd type="none" w="med" len="med"/>
+                      <a:tailEnd type="none" w="med" len="med"/>
+                    </a:lnB>
+                    <a:solidFill>
+                      <a:srgbClr val="F8F9FA"/>
+                    </a:solidFill>
+                  </a:tcPr>
+                </a:tc>
+                <a:tc>
+                  <a:txBody>
+                    <a:bodyPr/>
+                    <a:lstStyle/>
+                    <a:p>
+                      <a:pPr indent="0" marL="0">
+                        <a:buNone/>
+                      </a:pPr>
+                      <a:r>
+                        <a:rPr lang="en-US" sz="1200" dirty="0">
+                          <a:solidFill>
+                            <a:srgbClr val="1A1A2E"/>
+                          </a:solidFill>
+                        </a:rPr>
+                        <a:t>Phase 4 STO</a:t>
+                      </a:r>
+                      <a:endParaRPr lang="en-US" sz="1200" dirty="0"/>
+                    </a:p>
+                  </a:txBody>
+                  <a:tcPr marL="152400" marR="152400" marT="101600" marB="101600">
+                    <a:lnL w="6350" cap="flat" cmpd="sng" algn="ctr">
+                      <a:solidFill>
+                        <a:srgbClr val="DDDDDD"/>
+                      </a:solidFill>
+                      <a:prstDash val="solid"/>
+                      <a:round/>
+                      <a:headEnd type="none" w="med" len="med"/>
+                      <a:tailEnd type="none" w="med" len="med"/>
+                    </a:lnL>
+                    <a:lnR w="6350" cap="flat" cmpd="sng" algn="ctr">
+                      <a:solidFill>
+                        <a:srgbClr val="DDDDDD"/>
+                      </a:solidFill>
+                      <a:prstDash val="solid"/>
+                      <a:round/>
+                      <a:headEnd type="none" w="med" len="med"/>
+                      <a:tailEnd type="none" w="med" len="med"/>
+                    </a:lnR>
+                    <a:lnT w="6350" cap="flat" cmpd="sng" algn="ctr">
+                      <a:solidFill>
+                        <a:srgbClr val="DDDDDD"/>
+                      </a:solidFill>
+                      <a:prstDash val="solid"/>
+                      <a:round/>
+                      <a:headEnd type="none" w="med" len="med"/>
+                      <a:tailEnd type="none" w="med" len="med"/>
+                    </a:lnT>
+                    <a:lnB w="6350" cap="flat" cmpd="sng" algn="ctr">
+                      <a:solidFill>
+                        <a:srgbClr val="DDDDDD"/>
+                      </a:solidFill>
+                      <a:prstDash val="solid"/>
+                      <a:round/>
+                      <a:headEnd type="none" w="med" len="med"/>
+                      <a:tailEnd type="none" w="med" len="med"/>
+                    </a:lnB>
+                    <a:solidFill>
+                      <a:srgbClr val="F8F9FA"/>
+                    </a:solidFill>
+                  </a:tcPr>
+                </a:tc>
+                <a:tc>
+                  <a:txBody>
+                    <a:bodyPr/>
+                    <a:lstStyle/>
+                    <a:p>
+                      <a:pPr indent="0" marL="0">
+                        <a:buNone/>
+                      </a:pPr>
+                      <a:r>
+                        <a:rPr lang="en-US" sz="1200" dirty="0">
+                          <a:solidFill>
+                            <a:srgbClr val="1A1A2E"/>
+                          </a:solidFill>
+                        </a:rPr>
+                        <a:t>토큰증권 런칭, 글로벌 확장</a:t>
+                      </a:r>
+                      <a:endParaRPr lang="en-US" sz="1200" dirty="0"/>
+                    </a:p>
+                  </a:txBody>
+                  <a:tcPr marL="152400" marR="152400" marT="101600" marB="101600">
+                    <a:lnL w="6350" cap="flat" cmpd="sng" algn="ctr">
+                      <a:solidFill>
+                        <a:srgbClr val="DDDDDD"/>
+                      </a:solidFill>
+                      <a:prstDash val="solid"/>
+                      <a:round/>
+                      <a:headEnd type="none" w="med" len="med"/>
+                      <a:tailEnd type="none" w="med" len="med"/>
+                    </a:lnL>
+                    <a:lnR w="6350" cap="flat" cmpd="sng" algn="ctr">
+                      <a:solidFill>
+                        <a:srgbClr val="DDDDDD"/>
+                      </a:solidFill>
+                      <a:prstDash val="solid"/>
+                      <a:round/>
+                      <a:headEnd type="none" w="med" len="med"/>
+                      <a:tailEnd type="none" w="med" len="med"/>
+                    </a:lnR>
+                    <a:lnT w="6350" cap="flat" cmpd="sng" algn="ctr">
+                      <a:solidFill>
+                        <a:srgbClr val="DDDDDD"/>
+                      </a:solidFill>
+                      <a:prstDash val="solid"/>
+                      <a:round/>
+                      <a:headEnd type="none" w="med" len="med"/>
+                      <a:tailEnd type="none" w="med" len="med"/>
+                    </a:lnT>
+                    <a:lnB w="6350" cap="flat" cmpd="sng" algn="ctr">
+                      <a:solidFill>
+                        <a:srgbClr val="DDDDDD"/>
+                      </a:solidFill>
+                      <a:prstDash val="solid"/>
+                      <a:round/>
+                      <a:headEnd type="none" w="med" len="med"/>
+                      <a:tailEnd type="none" w="med" len="med"/>
+                    </a:lnB>
+                    <a:solidFill>
+                      <a:srgbClr val="F8F9FA"/>
+                    </a:solidFill>
+                  </a:tcPr>
+                </a:tc>
+              </a:tr>
+            </a:tbl>
+          </a:graphicData>
+        </a:graphic>
+      </p:graphicFrame>
+      <p:sp>
+        <p:nvSpPr>
+          <p:cNvPr id="4" name="Shape 1"/>
+          <p:cNvSpPr/>
+          <p:nvPr/>
+        </p:nvSpPr>
+        <p:spPr>
+          <a:xfrm>
+            <a:off x="2743200" y="5029200"/>
+            <a:ext cx="6400800" cy="1371600"/>
+          </a:xfrm>
+          <a:prstGeom prst="roundRect">
+            <a:avLst>
+              <a:gd name="adj" fmla="val 10000"/>
+            </a:avLst>
+          </a:prstGeom>
+          <a:solidFill>
+            <a:srgbClr val="1E2761"/>
+          </a:solidFill>
+          <a:ln/>
+        </p:spPr>
+      </p:sp>
+      <p:sp>
+        <p:nvSpPr>
+          <p:cNvPr id="5" name="Text 2"/>
+          <p:cNvSpPr/>
+          <p:nvPr/>
+        </p:nvSpPr>
+        <p:spPr>
+          <a:xfrm>
+            <a:off x="2743200" y="5120640"/>
+            <a:ext cx="6400800" cy="0"/>
+          </a:xfrm>
+          <a:prstGeom prst="rect">
+            <a:avLst/>
+          </a:prstGeom>
+          <a:noFill/>
+          <a:ln/>
+        </p:spPr>
+        <p:txBody>
+          <a:bodyPr wrap="square" rtlCol="0" anchor="ctr"/>
+          <a:lstStyle/>
+          <a:p>
+            <a:pPr algn="ctr" indent="0" marL="0">
+              <a:buNone/>
+            </a:pPr>
+            <a:r>
+              <a:rPr lang="en-US" sz="1200" dirty="0">
+                <a:solidFill>
+                  <a:srgbClr val="95A5A6"/>
+                </a:solidFill>
+                <a:latin typeface="Arial" pitchFamily="34" charset="0"/>
+                <a:ea typeface="Arial" pitchFamily="34" charset="-122"/>
+                <a:cs typeface="Arial" pitchFamily="34" charset="-120"/>
+              </a:rPr>
+              <a:t>총 개발 기간</a:t>
+            </a:r>
+            <a:endParaRPr lang="en-US" sz="1200" dirty="0"/>
+          </a:p>
+        </p:txBody>
+      </p:sp>
+      <p:sp>
+        <p:nvSpPr>
+          <p:cNvPr id="6" name="Text 3"/>
+          <p:cNvSpPr/>
+          <p:nvPr/>
+        </p:nvSpPr>
+        <p:spPr>
+          <a:xfrm>
+            <a:off x="2743200" y="5394960"/>
+            <a:ext cx="6400800" cy="0"/>
+          </a:xfrm>
+          <a:prstGeom prst="rect">
+            <a:avLst/>
+          </a:prstGeom>
+          <a:noFill/>
+          <a:ln/>
+        </p:spPr>
+        <p:txBody>
+          <a:bodyPr wrap="square" rtlCol="0" anchor="ctr"/>
+          <a:lstStyle/>
+          <a:p>
+            <a:pPr algn="ctr" indent="0" marL="0">
+              <a:buNone/>
+            </a:pPr>
+            <a:r>
+              <a:rPr lang="en-US" sz="3200" b="1" dirty="0">
+                <a:solidFill>
+                  <a:srgbClr val="FFFFFF"/>
+                </a:solidFill>
+                <a:latin typeface="Arial Black" pitchFamily="34" charset="0"/>
+                <a:ea typeface="Arial Black" pitchFamily="34" charset="-122"/>
+                <a:cs typeface="Arial Black" pitchFamily="34" charset="-120"/>
+              </a:rPr>
+              <a:t>73주 (약 18개월)</a:t>
+            </a:r>
+            <a:endParaRPr lang="en-US" sz="3200" dirty="0"/>
+          </a:p>
+        </p:txBody>
+      </p:sp>
+      <p:sp>
+        <p:nvSpPr>
+          <p:cNvPr id="7" name="Text 4"/>
+          <p:cNvSpPr/>
+          <p:nvPr/>
+        </p:nvSpPr>
+        <p:spPr>
+          <a:xfrm>
+            <a:off x="2743200" y="5943600"/>
+            <a:ext cx="6400800" cy="0"/>
+          </a:xfrm>
+          <a:prstGeom prst="rect">
+            <a:avLst/>
+          </a:prstGeom>
+          <a:noFill/>
+          <a:ln/>
+        </p:spPr>
+        <p:txBody>
+          <a:bodyPr wrap="square" rtlCol="0" anchor="ctr"/>
+          <a:lstStyle/>
+          <a:p>
+            <a:pPr algn="ctr" indent="0" marL="0">
+              <a:buNone/>
+            </a:pPr>
+            <a:r>
+              <a:rPr lang="en-US" sz="1400" dirty="0">
+                <a:solidFill>
+                  <a:srgbClr val="27AE60"/>
+                </a:solidFill>
+                <a:latin typeface="Arial" pitchFamily="34" charset="0"/>
+                <a:ea typeface="Arial" pitchFamily="34" charset="-122"/>
+                <a:cs typeface="Arial" pitchFamily="34" charset="-120"/>
+              </a:rPr>
+              <a:t>가속 시 56~62주 (약 14~15.5개월)</a:t>
+            </a:r>
+            <a:endParaRPr lang="en-US" sz="1400" dirty="0"/>
+          </a:p>
+        </p:txBody>
+      </p:sp>
+    </p:spTree>
+  </p:cSld>
+  <p:clrMapOvr>
+    <a:masterClrMapping/>
+  </p:clrMapOvr>
+</p:sld>
+</file>
+
+<file path=ppt/slides/slide11.xml><?xml version="1.0" encoding="utf-8"?>
+<p:sld xmlns:a="http://schemas.openxmlformats.org/drawingml/2006/main" xmlns:r="http://schemas.openxmlformats.org/officeDocument/2006/relationships" xmlns:p="http://schemas.openxmlformats.org/presentationml/2006/main">
+  <p:cSld name="Slide 11">
     <p:bg>
       <p:bgPr>
         <a:solidFill>
@@ -12454,9 +13894,50 @@
                 <a:ea typeface="Arial Black" pitchFamily="34" charset="-122"/>
                 <a:cs typeface="Arial Black" pitchFamily="34" charset="-120"/>
               </a:rPr>
-              <a:t>리스크 및 대응</a:t>
+              <a:t>AI 개발팀 구축 효과</a:t>
             </a:r>
             <a:endParaRPr lang="en-US" sz="2800" dirty="0"/>
+          </a:p>
+        </p:txBody>
+      </p:sp>
+      <p:sp>
+        <p:nvSpPr>
+          <p:cNvPr id="3" name="Text 1"/>
+          <p:cNvSpPr/>
+          <p:nvPr/>
+        </p:nvSpPr>
+        <p:spPr>
+          <a:xfrm>
+            <a:off x="457200" y="822960"/>
+            <a:ext cx="10972800" cy="0"/>
+          </a:xfrm>
+          <a:prstGeom prst="rect">
+            <a:avLst/>
+          </a:prstGeom>
+          <a:solidFill>
+            <a:srgbClr val="CADCFC"/>
+          </a:solidFill>
+          <a:ln/>
+        </p:spPr>
+        <p:txBody>
+          <a:bodyPr wrap="square" lIns="101600" tIns="152400" rIns="152400" bIns="101600" rtlCol="0" anchor="ctr"/>
+          <a:lstStyle/>
+          <a:p>
+            <a:pPr indent="0" marL="0">
+              <a:buNone/>
+            </a:pPr>
+            <a:r>
+              <a:rPr lang="en-US" sz="1300" dirty="0">
+                <a:solidFill>
+                  <a:srgbClr val="1E2761"/>
+                </a:solidFill>
+                <a:latin typeface="Arial" pitchFamily="34" charset="0"/>
+                <a:ea typeface="Arial" pitchFamily="34" charset="-122"/>
+                <a:cs typeface="Arial" pitchFamily="34" charset="-120"/>
+              </a:rPr>
+              <a:t>6개 AI 팀 + 16개 QA 에이전트 = 3~4명 개발팀 대체, 인건비 연 3.6억원 절감</a:t>
+            </a:r>
+            <a:endParaRPr lang="en-US" sz="1300" dirty="0"/>
           </a:p>
         </p:txBody>
       </p:sp>
@@ -12475,17 +13956,17 @@
           </p:nvPr>
         </p:nvGraphicFramePr>
         <p:xfrm>
-          <a:off x="457200" y="1097280"/>
-          <a:ext cx="10972800" cy="914400"/>
+          <a:off x="457200" y="1463040"/>
+          <a:ext cx="5486400" cy="914400"/>
         </p:xfrm>
         <a:graphic>
           <a:graphicData uri="http://schemas.openxmlformats.org/drawingml/2006/table">
             <a:tbl>
               <a:tblPr/>
               <a:tblGrid>
-                <a:gridCol w="2743200"/>
+                <a:gridCol w="1828800"/>
                 <a:gridCol w="1371600"/>
-                <a:gridCol w="6858000"/>
+                <a:gridCol w="2286000"/>
               </a:tblGrid>
               <a:tr h="0">
                 <a:tc>
@@ -12497,17 +13978,17 @@
                         <a:buNone/>
                       </a:pPr>
                       <a:r>
-                        <a:rPr lang="en-US" sz="1200" b="1" dirty="0">
+                        <a:rPr lang="en-US" sz="1100" b="1" dirty="0">
                           <a:solidFill>
                             <a:srgbClr val="FFFFFF"/>
                           </a:solidFill>
                         </a:rPr>
-                        <a:t>리스크</a:t>
+                        <a:t>AI 팀</a:t>
                       </a:r>
-                      <a:endParaRPr lang="en-US" sz="1200" dirty="0"/>
+                      <a:endParaRPr lang="en-US" sz="1100" dirty="0"/>
                     </a:p>
                   </a:txBody>
-                  <a:tcPr marL="127000" marR="127000" marT="76200" marB="76200">
+                  <a:tcPr marL="101600" marR="101600" marT="50800" marB="50800">
                     <a:lnL w="6350" cap="flat" cmpd="sng" algn="ctr">
                       <a:solidFill>
                         <a:srgbClr val="DDDDDD"/>
@@ -12558,17 +14039,17 @@
                         <a:buNone/>
                       </a:pPr>
                       <a:r>
-                        <a:rPr lang="en-US" sz="1200" b="1" dirty="0">
+                        <a:rPr lang="en-US" sz="1100" b="1" dirty="0">
                           <a:solidFill>
                             <a:srgbClr val="FFFFFF"/>
                           </a:solidFill>
                         </a:rPr>
-                        <a:t>심각도</a:t>
+                        <a:t>에이전트</a:t>
                       </a:r>
-                      <a:endParaRPr lang="en-US" sz="1200" dirty="0"/>
+                      <a:endParaRPr lang="en-US" sz="1100" dirty="0"/>
                     </a:p>
                   </a:txBody>
-                  <a:tcPr marL="127000" marR="127000" marT="76200" marB="76200">
+                  <a:tcPr marL="101600" marR="101600" marT="50800" marB="50800">
                     <a:lnL w="6350" cap="flat" cmpd="sng" algn="ctr">
                       <a:solidFill>
                         <a:srgbClr val="DDDDDD"/>
@@ -12619,17 +14100,17 @@
                         <a:buNone/>
                       </a:pPr>
                       <a:r>
-                        <a:rPr lang="en-US" sz="1200" b="1" dirty="0">
+                        <a:rPr lang="en-US" sz="1100" b="1" dirty="0">
                           <a:solidFill>
                             <a:srgbClr val="FFFFFF"/>
                           </a:solidFill>
                         </a:rPr>
-                        <a:t>대응 전략</a:t>
+                        <a:t>대체 효과</a:t>
                       </a:r>
-                      <a:endParaRPr lang="en-US" sz="1200" dirty="0"/>
+                      <a:endParaRPr lang="en-US" sz="1100" dirty="0"/>
                     </a:p>
                   </a:txBody>
-                  <a:tcPr marL="127000" marR="127000" marT="76200" marB="76200">
+                  <a:tcPr marL="101600" marR="101600" marT="50800" marB="50800">
                     <a:lnL w="6350" cap="flat" cmpd="sng" algn="ctr">
                       <a:solidFill>
                         <a:srgbClr val="DDDDDD"/>
@@ -12687,73 +14168,12 @@
                             <a:srgbClr val="1A1A2E"/>
                           </a:solidFill>
                         </a:rPr>
-                        <a:t>MAU 하락 지속</a:t>
+                        <a:t>T1 일정기획</a:t>
                       </a:r>
                       <a:endParaRPr lang="en-US" sz="1100" dirty="0"/>
                     </a:p>
                   </a:txBody>
-                  <a:tcPr marL="127000" marR="127000" marT="76200" marB="76200">
-                    <a:lnL w="6350" cap="flat" cmpd="sng" algn="ctr">
-                      <a:solidFill>
-                        <a:srgbClr val="DDDDDD"/>
-                      </a:solidFill>
-                      <a:prstDash val="solid"/>
-                      <a:round/>
-                      <a:headEnd type="none" w="med" len="med"/>
-                      <a:tailEnd type="none" w="med" len="med"/>
-                    </a:lnL>
-                    <a:lnR w="6350" cap="flat" cmpd="sng" algn="ctr">
-                      <a:solidFill>
-                        <a:srgbClr val="DDDDDD"/>
-                      </a:solidFill>
-                      <a:prstDash val="solid"/>
-                      <a:round/>
-                      <a:headEnd type="none" w="med" len="med"/>
-                      <a:tailEnd type="none" w="med" len="med"/>
-                    </a:lnR>
-                    <a:lnT w="6350" cap="flat" cmpd="sng" algn="ctr">
-                      <a:solidFill>
-                        <a:srgbClr val="DDDDDD"/>
-                      </a:solidFill>
-                      <a:prstDash val="solid"/>
-                      <a:round/>
-                      <a:headEnd type="none" w="med" len="med"/>
-                      <a:tailEnd type="none" w="med" len="med"/>
-                    </a:lnT>
-                    <a:lnB w="6350" cap="flat" cmpd="sng" algn="ctr">
-                      <a:solidFill>
-                        <a:srgbClr val="DDDDDD"/>
-                      </a:solidFill>
-                      <a:prstDash val="solid"/>
-                      <a:round/>
-                      <a:headEnd type="none" w="med" len="med"/>
-                      <a:tailEnd type="none" w="med" len="med"/>
-                    </a:lnB>
-                    <a:solidFill>
-                      <a:srgbClr val="F8F9FA"/>
-                    </a:solidFill>
-                  </a:tcPr>
-                </a:tc>
-                <a:tc>
-                  <a:txBody>
-                    <a:bodyPr/>
-                    <a:lstStyle/>
-                    <a:p>
-                      <a:pPr indent="0" marL="0">
-                        <a:buNone/>
-                      </a:pPr>
-                      <a:r>
-                        <a:rPr lang="en-US" sz="1100" b="1" dirty="0">
-                          <a:solidFill>
-                            <a:srgbClr val="E74C3C"/>
-                          </a:solidFill>
-                        </a:rPr>
-                        <a:t>높음</a:t>
-                      </a:r>
-                      <a:endParaRPr lang="en-US" sz="1100" dirty="0"/>
-                    </a:p>
-                  </a:txBody>
-                  <a:tcPr marL="127000" marR="127000" marT="76200" marB="76200">
+                  <a:tcPr marL="101600" marR="101600" marT="50800" marB="50800">
                     <a:lnL w="6350" cap="flat" cmpd="sng" algn="ctr">
                       <a:solidFill>
                         <a:srgbClr val="DDDDDD"/>
@@ -12809,12 +14229,73 @@
                             <a:srgbClr val="1A1A2E"/>
                           </a:solidFill>
                         </a:rPr>
-                        <a:t>리뉴얼 + GTM 전략 (기존 13만 회원 활용)</a:t>
+                        <a:t>2개</a:t>
                       </a:r>
                       <a:endParaRPr lang="en-US" sz="1100" dirty="0"/>
                     </a:p>
                   </a:txBody>
-                  <a:tcPr marL="127000" marR="127000" marT="76200" marB="76200">
+                  <a:tcPr marL="101600" marR="101600" marT="50800" marB="50800">
+                    <a:lnL w="6350" cap="flat" cmpd="sng" algn="ctr">
+                      <a:solidFill>
+                        <a:srgbClr val="DDDDDD"/>
+                      </a:solidFill>
+                      <a:prstDash val="solid"/>
+                      <a:round/>
+                      <a:headEnd type="none" w="med" len="med"/>
+                      <a:tailEnd type="none" w="med" len="med"/>
+                    </a:lnL>
+                    <a:lnR w="6350" cap="flat" cmpd="sng" algn="ctr">
+                      <a:solidFill>
+                        <a:srgbClr val="DDDDDD"/>
+                      </a:solidFill>
+                      <a:prstDash val="solid"/>
+                      <a:round/>
+                      <a:headEnd type="none" w="med" len="med"/>
+                      <a:tailEnd type="none" w="med" len="med"/>
+                    </a:lnR>
+                    <a:lnT w="6350" cap="flat" cmpd="sng" algn="ctr">
+                      <a:solidFill>
+                        <a:srgbClr val="DDDDDD"/>
+                      </a:solidFill>
+                      <a:prstDash val="solid"/>
+                      <a:round/>
+                      <a:headEnd type="none" w="med" len="med"/>
+                      <a:tailEnd type="none" w="med" len="med"/>
+                    </a:lnT>
+                    <a:lnB w="6350" cap="flat" cmpd="sng" algn="ctr">
+                      <a:solidFill>
+                        <a:srgbClr val="DDDDDD"/>
+                      </a:solidFill>
+                      <a:prstDash val="solid"/>
+                      <a:round/>
+                      <a:headEnd type="none" w="med" len="med"/>
+                      <a:tailEnd type="none" w="med" len="med"/>
+                    </a:lnB>
+                    <a:solidFill>
+                      <a:srgbClr val="F8F9FA"/>
+                    </a:solidFill>
+                  </a:tcPr>
+                </a:tc>
+                <a:tc>
+                  <a:txBody>
+                    <a:bodyPr/>
+                    <a:lstStyle/>
+                    <a:p>
+                      <a:pPr indent="0" marL="0">
+                        <a:buNone/>
+                      </a:pPr>
+                      <a:r>
+                        <a:rPr lang="en-US" sz="1100" dirty="0">
+                          <a:solidFill>
+                            <a:srgbClr val="1A1A2E"/>
+                          </a:solidFill>
+                        </a:rPr>
+                        <a:t>PM 대체</a:t>
+                      </a:r>
+                      <a:endParaRPr lang="en-US" sz="1100" dirty="0"/>
+                    </a:p>
+                  </a:txBody>
+                  <a:tcPr marL="101600" marR="101600" marT="50800" marB="50800">
                     <a:lnL w="6350" cap="flat" cmpd="sng" algn="ctr">
                       <a:solidFill>
                         <a:srgbClr val="DDDDDD"/>
@@ -12872,73 +14353,12 @@
                             <a:srgbClr val="1A1A2E"/>
                           </a:solidFill>
                         </a:rPr>
-                        <a:t>iOS Wi-Fi 스캔 차단</a:t>
+                        <a:t>T2 구현설계</a:t>
                       </a:r>
                       <a:endParaRPr lang="en-US" sz="1100" dirty="0"/>
                     </a:p>
                   </a:txBody>
-                  <a:tcPr marL="127000" marR="127000" marT="76200" marB="76200">
-                    <a:lnL w="6350" cap="flat" cmpd="sng" algn="ctr">
-                      <a:solidFill>
-                        <a:srgbClr val="DDDDDD"/>
-                      </a:solidFill>
-                      <a:prstDash val="solid"/>
-                      <a:round/>
-                      <a:headEnd type="none" w="med" len="med"/>
-                      <a:tailEnd type="none" w="med" len="med"/>
-                    </a:lnL>
-                    <a:lnR w="6350" cap="flat" cmpd="sng" algn="ctr">
-                      <a:solidFill>
-                        <a:srgbClr val="DDDDDD"/>
-                      </a:solidFill>
-                      <a:prstDash val="solid"/>
-                      <a:round/>
-                      <a:headEnd type="none" w="med" len="med"/>
-                      <a:tailEnd type="none" w="med" len="med"/>
-                    </a:lnR>
-                    <a:lnT w="6350" cap="flat" cmpd="sng" algn="ctr">
-                      <a:solidFill>
-                        <a:srgbClr val="DDDDDD"/>
-                      </a:solidFill>
-                      <a:prstDash val="solid"/>
-                      <a:round/>
-                      <a:headEnd type="none" w="med" len="med"/>
-                      <a:tailEnd type="none" w="med" len="med"/>
-                    </a:lnT>
-                    <a:lnB w="6350" cap="flat" cmpd="sng" algn="ctr">
-                      <a:solidFill>
-                        <a:srgbClr val="DDDDDD"/>
-                      </a:solidFill>
-                      <a:prstDash val="solid"/>
-                      <a:round/>
-                      <a:headEnd type="none" w="med" len="med"/>
-                      <a:tailEnd type="none" w="med" len="med"/>
-                    </a:lnB>
-                    <a:solidFill>
-                      <a:srgbClr val="F8F9FA"/>
-                    </a:solidFill>
-                  </a:tcPr>
-                </a:tc>
-                <a:tc>
-                  <a:txBody>
-                    <a:bodyPr/>
-                    <a:lstStyle/>
-                    <a:p>
-                      <a:pPr indent="0" marL="0">
-                        <a:buNone/>
-                      </a:pPr>
-                      <a:r>
-                        <a:rPr lang="en-US" sz="1100" b="1" dirty="0">
-                          <a:solidFill>
-                            <a:srgbClr val="E74C3C"/>
-                          </a:solidFill>
-                        </a:rPr>
-                        <a:t>높음</a:t>
-                      </a:r>
-                      <a:endParaRPr lang="en-US" sz="1100" dirty="0"/>
-                    </a:p>
-                  </a:txBody>
-                  <a:tcPr marL="127000" marR="127000" marT="76200" marB="76200">
+                  <a:tcPr marL="101600" marR="101600" marT="50800" marB="50800">
                     <a:lnL w="6350" cap="flat" cmpd="sng" algn="ctr">
                       <a:solidFill>
                         <a:srgbClr val="DDDDDD"/>
@@ -12994,12 +14414,73 @@
                             <a:srgbClr val="1A1A2E"/>
                           </a:solidFill>
                         </a:rPr>
-                        <a:t>GPS 속도 + 정류장 지오펜스 + CMMotion 대안</a:t>
+                        <a:t>6개</a:t>
                       </a:r>
                       <a:endParaRPr lang="en-US" sz="1100" dirty="0"/>
                     </a:p>
                   </a:txBody>
-                  <a:tcPr marL="127000" marR="127000" marT="76200" marB="76200">
+                  <a:tcPr marL="101600" marR="101600" marT="50800" marB="50800">
+                    <a:lnL w="6350" cap="flat" cmpd="sng" algn="ctr">
+                      <a:solidFill>
+                        <a:srgbClr val="DDDDDD"/>
+                      </a:solidFill>
+                      <a:prstDash val="solid"/>
+                      <a:round/>
+                      <a:headEnd type="none" w="med" len="med"/>
+                      <a:tailEnd type="none" w="med" len="med"/>
+                    </a:lnL>
+                    <a:lnR w="6350" cap="flat" cmpd="sng" algn="ctr">
+                      <a:solidFill>
+                        <a:srgbClr val="DDDDDD"/>
+                      </a:solidFill>
+                      <a:prstDash val="solid"/>
+                      <a:round/>
+                      <a:headEnd type="none" w="med" len="med"/>
+                      <a:tailEnd type="none" w="med" len="med"/>
+                    </a:lnR>
+                    <a:lnT w="6350" cap="flat" cmpd="sng" algn="ctr">
+                      <a:solidFill>
+                        <a:srgbClr val="DDDDDD"/>
+                      </a:solidFill>
+                      <a:prstDash val="solid"/>
+                      <a:round/>
+                      <a:headEnd type="none" w="med" len="med"/>
+                      <a:tailEnd type="none" w="med" len="med"/>
+                    </a:lnT>
+                    <a:lnB w="6350" cap="flat" cmpd="sng" algn="ctr">
+                      <a:solidFill>
+                        <a:srgbClr val="DDDDDD"/>
+                      </a:solidFill>
+                      <a:prstDash val="solid"/>
+                      <a:round/>
+                      <a:headEnd type="none" w="med" len="med"/>
+                      <a:tailEnd type="none" w="med" len="med"/>
+                    </a:lnB>
+                    <a:solidFill>
+                      <a:srgbClr val="F8F9FA"/>
+                    </a:solidFill>
+                  </a:tcPr>
+                </a:tc>
+                <a:tc>
+                  <a:txBody>
+                    <a:bodyPr/>
+                    <a:lstStyle/>
+                    <a:p>
+                      <a:pPr indent="0" marL="0">
+                        <a:buNone/>
+                      </a:pPr>
+                      <a:r>
+                        <a:rPr lang="en-US" sz="1100" dirty="0">
+                          <a:solidFill>
+                            <a:srgbClr val="1A1A2E"/>
+                          </a:solidFill>
+                        </a:rPr>
+                        <a:t>시니어 개발자 대체</a:t>
+                      </a:r>
+                      <a:endParaRPr lang="en-US" sz="1100" dirty="0"/>
+                    </a:p>
+                  </a:txBody>
+                  <a:tcPr marL="101600" marR="101600" marT="50800" marB="50800">
                     <a:lnL w="6350" cap="flat" cmpd="sng" algn="ctr">
                       <a:solidFill>
                         <a:srgbClr val="DDDDDD"/>
@@ -13057,73 +14538,12 @@
                             <a:srgbClr val="1A1A2E"/>
                           </a:solidFill>
                         </a:rPr>
-                        <a:t>1인 개발 체제</a:t>
+                        <a:t>T3 개발</a:t>
                       </a:r>
                       <a:endParaRPr lang="en-US" sz="1100" dirty="0"/>
                     </a:p>
                   </a:txBody>
-                  <a:tcPr marL="127000" marR="127000" marT="76200" marB="76200">
-                    <a:lnL w="6350" cap="flat" cmpd="sng" algn="ctr">
-                      <a:solidFill>
-                        <a:srgbClr val="DDDDDD"/>
-                      </a:solidFill>
-                      <a:prstDash val="solid"/>
-                      <a:round/>
-                      <a:headEnd type="none" w="med" len="med"/>
-                      <a:tailEnd type="none" w="med" len="med"/>
-                    </a:lnL>
-                    <a:lnR w="6350" cap="flat" cmpd="sng" algn="ctr">
-                      <a:solidFill>
-                        <a:srgbClr val="DDDDDD"/>
-                      </a:solidFill>
-                      <a:prstDash val="solid"/>
-                      <a:round/>
-                      <a:headEnd type="none" w="med" len="med"/>
-                      <a:tailEnd type="none" w="med" len="med"/>
-                    </a:lnR>
-                    <a:lnT w="6350" cap="flat" cmpd="sng" algn="ctr">
-                      <a:solidFill>
-                        <a:srgbClr val="DDDDDD"/>
-                      </a:solidFill>
-                      <a:prstDash val="solid"/>
-                      <a:round/>
-                      <a:headEnd type="none" w="med" len="med"/>
-                      <a:tailEnd type="none" w="med" len="med"/>
-                    </a:lnT>
-                    <a:lnB w="6350" cap="flat" cmpd="sng" algn="ctr">
-                      <a:solidFill>
-                        <a:srgbClr val="DDDDDD"/>
-                      </a:solidFill>
-                      <a:prstDash val="solid"/>
-                      <a:round/>
-                      <a:headEnd type="none" w="med" len="med"/>
-                      <a:tailEnd type="none" w="med" len="med"/>
-                    </a:lnB>
-                    <a:solidFill>
-                      <a:srgbClr val="F8F9FA"/>
-                    </a:solidFill>
-                  </a:tcPr>
-                </a:tc>
-                <a:tc>
-                  <a:txBody>
-                    <a:bodyPr/>
-                    <a:lstStyle/>
-                    <a:p>
-                      <a:pPr indent="0" marL="0">
-                        <a:buNone/>
-                      </a:pPr>
-                      <a:r>
-                        <a:rPr lang="en-US" sz="1100" b="1" dirty="0">
-                          <a:solidFill>
-                            <a:srgbClr val="1A1A2E"/>
-                          </a:solidFill>
-                        </a:rPr>
-                        <a:t>중간</a:t>
-                      </a:r>
-                      <a:endParaRPr lang="en-US" sz="1100" dirty="0"/>
-                    </a:p>
-                  </a:txBody>
-                  <a:tcPr marL="127000" marR="127000" marT="76200" marB="76200">
+                  <a:tcPr marL="101600" marR="101600" marT="50800" marB="50800">
                     <a:lnL w="6350" cap="flat" cmpd="sng" algn="ctr">
                       <a:solidFill>
                         <a:srgbClr val="DDDDDD"/>
@@ -13179,12 +14599,73 @@
                             <a:srgbClr val="1A1A2E"/>
                           </a:solidFill>
                         </a:rPr>
-                        <a:t>Claude AI 병렬 코드생성, Spec-Kit 자동화</a:t>
+                        <a:t>3~30개</a:t>
                       </a:r>
                       <a:endParaRPr lang="en-US" sz="1100" dirty="0"/>
                     </a:p>
                   </a:txBody>
-                  <a:tcPr marL="127000" marR="127000" marT="76200" marB="76200">
+                  <a:tcPr marL="101600" marR="101600" marT="50800" marB="50800">
+                    <a:lnL w="6350" cap="flat" cmpd="sng" algn="ctr">
+                      <a:solidFill>
+                        <a:srgbClr val="DDDDDD"/>
+                      </a:solidFill>
+                      <a:prstDash val="solid"/>
+                      <a:round/>
+                      <a:headEnd type="none" w="med" len="med"/>
+                      <a:tailEnd type="none" w="med" len="med"/>
+                    </a:lnL>
+                    <a:lnR w="6350" cap="flat" cmpd="sng" algn="ctr">
+                      <a:solidFill>
+                        <a:srgbClr val="DDDDDD"/>
+                      </a:solidFill>
+                      <a:prstDash val="solid"/>
+                      <a:round/>
+                      <a:headEnd type="none" w="med" len="med"/>
+                      <a:tailEnd type="none" w="med" len="med"/>
+                    </a:lnR>
+                    <a:lnT w="6350" cap="flat" cmpd="sng" algn="ctr">
+                      <a:solidFill>
+                        <a:srgbClr val="DDDDDD"/>
+                      </a:solidFill>
+                      <a:prstDash val="solid"/>
+                      <a:round/>
+                      <a:headEnd type="none" w="med" len="med"/>
+                      <a:tailEnd type="none" w="med" len="med"/>
+                    </a:lnT>
+                    <a:lnB w="6350" cap="flat" cmpd="sng" algn="ctr">
+                      <a:solidFill>
+                        <a:srgbClr val="DDDDDD"/>
+                      </a:solidFill>
+                      <a:prstDash val="solid"/>
+                      <a:round/>
+                      <a:headEnd type="none" w="med" len="med"/>
+                      <a:tailEnd type="none" w="med" len="med"/>
+                    </a:lnB>
+                    <a:solidFill>
+                      <a:srgbClr val="F8F9FA"/>
+                    </a:solidFill>
+                  </a:tcPr>
+                </a:tc>
+                <a:tc>
+                  <a:txBody>
+                    <a:bodyPr/>
+                    <a:lstStyle/>
+                    <a:p>
+                      <a:pPr indent="0" marL="0">
+                        <a:buNone/>
+                      </a:pPr>
+                      <a:r>
+                        <a:rPr lang="en-US" sz="1100" dirty="0">
+                          <a:solidFill>
+                            <a:srgbClr val="1A1A2E"/>
+                          </a:solidFill>
+                        </a:rPr>
+                        <a:t>개발자 3명 대체</a:t>
+                      </a:r>
+                      <a:endParaRPr lang="en-US" sz="1100" dirty="0"/>
+                    </a:p>
+                  </a:txBody>
+                  <a:tcPr marL="101600" marR="101600" marT="50800" marB="50800">
                     <a:lnL w="6350" cap="flat" cmpd="sng" algn="ctr">
                       <a:solidFill>
                         <a:srgbClr val="DDDDDD"/>
@@ -13242,73 +14723,12 @@
                             <a:srgbClr val="1A1A2E"/>
                           </a:solidFill>
                         </a:rPr>
-                        <a:t>STO 규제 불확실성</a:t>
+                        <a:t>T4 QA</a:t>
                       </a:r>
                       <a:endParaRPr lang="en-US" sz="1100" dirty="0"/>
                     </a:p>
                   </a:txBody>
-                  <a:tcPr marL="127000" marR="127000" marT="76200" marB="76200">
-                    <a:lnL w="6350" cap="flat" cmpd="sng" algn="ctr">
-                      <a:solidFill>
-                        <a:srgbClr val="DDDDDD"/>
-                      </a:solidFill>
-                      <a:prstDash val="solid"/>
-                      <a:round/>
-                      <a:headEnd type="none" w="med" len="med"/>
-                      <a:tailEnd type="none" w="med" len="med"/>
-                    </a:lnL>
-                    <a:lnR w="6350" cap="flat" cmpd="sng" algn="ctr">
-                      <a:solidFill>
-                        <a:srgbClr val="DDDDDD"/>
-                      </a:solidFill>
-                      <a:prstDash val="solid"/>
-                      <a:round/>
-                      <a:headEnd type="none" w="med" len="med"/>
-                      <a:tailEnd type="none" w="med" len="med"/>
-                    </a:lnR>
-                    <a:lnT w="6350" cap="flat" cmpd="sng" algn="ctr">
-                      <a:solidFill>
-                        <a:srgbClr val="DDDDDD"/>
-                      </a:solidFill>
-                      <a:prstDash val="solid"/>
-                      <a:round/>
-                      <a:headEnd type="none" w="med" len="med"/>
-                      <a:tailEnd type="none" w="med" len="med"/>
-                    </a:lnT>
-                    <a:lnB w="6350" cap="flat" cmpd="sng" algn="ctr">
-                      <a:solidFill>
-                        <a:srgbClr val="DDDDDD"/>
-                      </a:solidFill>
-                      <a:prstDash val="solid"/>
-                      <a:round/>
-                      <a:headEnd type="none" w="med" len="med"/>
-                      <a:tailEnd type="none" w="med" len="med"/>
-                    </a:lnB>
-                    <a:solidFill>
-                      <a:srgbClr val="F8F9FA"/>
-                    </a:solidFill>
-                  </a:tcPr>
-                </a:tc>
-                <a:tc>
-                  <a:txBody>
-                    <a:bodyPr/>
-                    <a:lstStyle/>
-                    <a:p>
-                      <a:pPr indent="0" marL="0">
-                        <a:buNone/>
-                      </a:pPr>
-                      <a:r>
-                        <a:rPr lang="en-US" sz="1100" b="1" dirty="0">
-                          <a:solidFill>
-                            <a:srgbClr val="1A1A2E"/>
-                          </a:solidFill>
-                        </a:rPr>
-                        <a:t>중간</a:t>
-                      </a:r>
-                      <a:endParaRPr lang="en-US" sz="1100" dirty="0"/>
-                    </a:p>
-                  </a:txBody>
-                  <a:tcPr marL="127000" marR="127000" marT="76200" marB="76200">
+                  <a:tcPr marL="101600" marR="101600" marT="50800" marB="50800">
                     <a:lnL w="6350" cap="flat" cmpd="sng" algn="ctr">
                       <a:solidFill>
                         <a:srgbClr val="DDDDDD"/>
@@ -13364,12 +14784,73 @@
                             <a:srgbClr val="1A1A2E"/>
                           </a:solidFill>
                         </a:rPr>
-                        <a:t>FSC 사전컨설팅 + 규제 샌드박스 참여</a:t>
+                        <a:t>16개</a:t>
                       </a:r>
                       <a:endParaRPr lang="en-US" sz="1100" dirty="0"/>
                     </a:p>
                   </a:txBody>
-                  <a:tcPr marL="127000" marR="127000" marT="76200" marB="76200">
+                  <a:tcPr marL="101600" marR="101600" marT="50800" marB="50800">
+                    <a:lnL w="6350" cap="flat" cmpd="sng" algn="ctr">
+                      <a:solidFill>
+                        <a:srgbClr val="DDDDDD"/>
+                      </a:solidFill>
+                      <a:prstDash val="solid"/>
+                      <a:round/>
+                      <a:headEnd type="none" w="med" len="med"/>
+                      <a:tailEnd type="none" w="med" len="med"/>
+                    </a:lnL>
+                    <a:lnR w="6350" cap="flat" cmpd="sng" algn="ctr">
+                      <a:solidFill>
+                        <a:srgbClr val="DDDDDD"/>
+                      </a:solidFill>
+                      <a:prstDash val="solid"/>
+                      <a:round/>
+                      <a:headEnd type="none" w="med" len="med"/>
+                      <a:tailEnd type="none" w="med" len="med"/>
+                    </a:lnR>
+                    <a:lnT w="6350" cap="flat" cmpd="sng" algn="ctr">
+                      <a:solidFill>
+                        <a:srgbClr val="DDDDDD"/>
+                      </a:solidFill>
+                      <a:prstDash val="solid"/>
+                      <a:round/>
+                      <a:headEnd type="none" w="med" len="med"/>
+                      <a:tailEnd type="none" w="med" len="med"/>
+                    </a:lnT>
+                    <a:lnB w="6350" cap="flat" cmpd="sng" algn="ctr">
+                      <a:solidFill>
+                        <a:srgbClr val="DDDDDD"/>
+                      </a:solidFill>
+                      <a:prstDash val="solid"/>
+                      <a:round/>
+                      <a:headEnd type="none" w="med" len="med"/>
+                      <a:tailEnd type="none" w="med" len="med"/>
+                    </a:lnB>
+                    <a:solidFill>
+                      <a:srgbClr val="F8F9FA"/>
+                    </a:solidFill>
+                  </a:tcPr>
+                </a:tc>
+                <a:tc>
+                  <a:txBody>
+                    <a:bodyPr/>
+                    <a:lstStyle/>
+                    <a:p>
+                      <a:pPr indent="0" marL="0">
+                        <a:buNone/>
+                      </a:pPr>
+                      <a:r>
+                        <a:rPr lang="en-US" sz="1100" dirty="0">
+                          <a:solidFill>
+                            <a:srgbClr val="1A1A2E"/>
+                          </a:solidFill>
+                        </a:rPr>
+                        <a:t>QA 전문가 대체</a:t>
+                      </a:r>
+                      <a:endParaRPr lang="en-US" sz="1100" dirty="0"/>
+                    </a:p>
+                  </a:txBody>
+                  <a:tcPr marL="101600" marR="101600" marT="50800" marB="50800">
                     <a:lnL w="6350" cap="flat" cmpd="sng" algn="ctr">
                       <a:solidFill>
                         <a:srgbClr val="DDDDDD"/>
@@ -13427,73 +14908,12 @@
                             <a:srgbClr val="1A1A2E"/>
                           </a:solidFill>
                         </a:rPr>
-                        <a:t>딜러 익명성 유출</a:t>
+                        <a:t>T5 배포</a:t>
                       </a:r>
                       <a:endParaRPr lang="en-US" sz="1100" dirty="0"/>
                     </a:p>
                   </a:txBody>
-                  <a:tcPr marL="127000" marR="127000" marT="76200" marB="76200">
-                    <a:lnL w="6350" cap="flat" cmpd="sng" algn="ctr">
-                      <a:solidFill>
-                        <a:srgbClr val="DDDDDD"/>
-                      </a:solidFill>
-                      <a:prstDash val="solid"/>
-                      <a:round/>
-                      <a:headEnd type="none" w="med" len="med"/>
-                      <a:tailEnd type="none" w="med" len="med"/>
-                    </a:lnL>
-                    <a:lnR w="6350" cap="flat" cmpd="sng" algn="ctr">
-                      <a:solidFill>
-                        <a:srgbClr val="DDDDDD"/>
-                      </a:solidFill>
-                      <a:prstDash val="solid"/>
-                      <a:round/>
-                      <a:headEnd type="none" w="med" len="med"/>
-                      <a:tailEnd type="none" w="med" len="med"/>
-                    </a:lnR>
-                    <a:lnT w="6350" cap="flat" cmpd="sng" algn="ctr">
-                      <a:solidFill>
-                        <a:srgbClr val="DDDDDD"/>
-                      </a:solidFill>
-                      <a:prstDash val="solid"/>
-                      <a:round/>
-                      <a:headEnd type="none" w="med" len="med"/>
-                      <a:tailEnd type="none" w="med" len="med"/>
-                    </a:lnT>
-                    <a:lnB w="6350" cap="flat" cmpd="sng" algn="ctr">
-                      <a:solidFill>
-                        <a:srgbClr val="DDDDDD"/>
-                      </a:solidFill>
-                      <a:prstDash val="solid"/>
-                      <a:round/>
-                      <a:headEnd type="none" w="med" len="med"/>
-                      <a:tailEnd type="none" w="med" len="med"/>
-                    </a:lnB>
-                    <a:solidFill>
-                      <a:srgbClr val="F8F9FA"/>
-                    </a:solidFill>
-                  </a:tcPr>
-                </a:tc>
-                <a:tc>
-                  <a:txBody>
-                    <a:bodyPr/>
-                    <a:lstStyle/>
-                    <a:p>
-                      <a:pPr indent="0" marL="0">
-                        <a:buNone/>
-                      </a:pPr>
-                      <a:r>
-                        <a:rPr lang="en-US" sz="1100" b="1" dirty="0">
-                          <a:solidFill>
-                            <a:srgbClr val="E74C3C"/>
-                          </a:solidFill>
-                        </a:rPr>
-                        <a:t>높음</a:t>
-                      </a:r>
-                      <a:endParaRPr lang="en-US" sz="1100" dirty="0"/>
-                    </a:p>
-                  </a:txBody>
-                  <a:tcPr marL="127000" marR="127000" marT="76200" marB="76200">
+                  <a:tcPr marL="101600" marR="101600" marT="50800" marB="50800">
                     <a:lnL w="6350" cap="flat" cmpd="sng" algn="ctr">
                       <a:solidFill>
                         <a:srgbClr val="DDDDDD"/>
@@ -13549,12 +14969,73 @@
                             <a:srgbClr val="1A1A2E"/>
                           </a:solidFill>
                         </a:rPr>
-                        <a:t>API 필터링 + 접근 제한 + 감사 로그</a:t>
+                        <a:t>2개</a:t>
                       </a:r>
                       <a:endParaRPr lang="en-US" sz="1100" dirty="0"/>
                     </a:p>
                   </a:txBody>
-                  <a:tcPr marL="127000" marR="127000" marT="76200" marB="76200">
+                  <a:tcPr marL="101600" marR="101600" marT="50800" marB="50800">
+                    <a:lnL w="6350" cap="flat" cmpd="sng" algn="ctr">
+                      <a:solidFill>
+                        <a:srgbClr val="DDDDDD"/>
+                      </a:solidFill>
+                      <a:prstDash val="solid"/>
+                      <a:round/>
+                      <a:headEnd type="none" w="med" len="med"/>
+                      <a:tailEnd type="none" w="med" len="med"/>
+                    </a:lnL>
+                    <a:lnR w="6350" cap="flat" cmpd="sng" algn="ctr">
+                      <a:solidFill>
+                        <a:srgbClr val="DDDDDD"/>
+                      </a:solidFill>
+                      <a:prstDash val="solid"/>
+                      <a:round/>
+                      <a:headEnd type="none" w="med" len="med"/>
+                      <a:tailEnd type="none" w="med" len="med"/>
+                    </a:lnR>
+                    <a:lnT w="6350" cap="flat" cmpd="sng" algn="ctr">
+                      <a:solidFill>
+                        <a:srgbClr val="DDDDDD"/>
+                      </a:solidFill>
+                      <a:prstDash val="solid"/>
+                      <a:round/>
+                      <a:headEnd type="none" w="med" len="med"/>
+                      <a:tailEnd type="none" w="med" len="med"/>
+                    </a:lnT>
+                    <a:lnB w="6350" cap="flat" cmpd="sng" algn="ctr">
+                      <a:solidFill>
+                        <a:srgbClr val="DDDDDD"/>
+                      </a:solidFill>
+                      <a:prstDash val="solid"/>
+                      <a:round/>
+                      <a:headEnd type="none" w="med" len="med"/>
+                      <a:tailEnd type="none" w="med" len="med"/>
+                    </a:lnB>
+                    <a:solidFill>
+                      <a:srgbClr val="F8F9FA"/>
+                    </a:solidFill>
+                  </a:tcPr>
+                </a:tc>
+                <a:tc>
+                  <a:txBody>
+                    <a:bodyPr/>
+                    <a:lstStyle/>
+                    <a:p>
+                      <a:pPr indent="0" marL="0">
+                        <a:buNone/>
+                      </a:pPr>
+                      <a:r>
+                        <a:rPr lang="en-US" sz="1100" dirty="0">
+                          <a:solidFill>
+                            <a:srgbClr val="1A1A2E"/>
+                          </a:solidFill>
+                        </a:rPr>
+                        <a:t>DevOps 대체</a:t>
+                      </a:r>
+                      <a:endParaRPr lang="en-US" sz="1100" dirty="0"/>
+                    </a:p>
+                  </a:txBody>
+                  <a:tcPr marL="101600" marR="101600" marT="50800" marB="50800">
                     <a:lnL w="6350" cap="flat" cmpd="sng" algn="ctr">
                       <a:solidFill>
                         <a:srgbClr val="DDDDDD"/>
@@ -13612,12 +15093,390 @@
                             <a:srgbClr val="1A1A2E"/>
                           </a:solidFill>
                         </a:rPr>
-                        <a:t>토큰 가격 붕괴</a:t>
+                        <a:t>T6 보안</a:t>
                       </a:r>
                       <a:endParaRPr lang="en-US" sz="1100" dirty="0"/>
                     </a:p>
                   </a:txBody>
-                  <a:tcPr marL="127000" marR="127000" marT="76200" marB="76200">
+                  <a:tcPr marL="101600" marR="101600" marT="50800" marB="50800">
+                    <a:lnL w="6350" cap="flat" cmpd="sng" algn="ctr">
+                      <a:solidFill>
+                        <a:srgbClr val="DDDDDD"/>
+                      </a:solidFill>
+                      <a:prstDash val="solid"/>
+                      <a:round/>
+                      <a:headEnd type="none" w="med" len="med"/>
+                      <a:tailEnd type="none" w="med" len="med"/>
+                    </a:lnL>
+                    <a:lnR w="6350" cap="flat" cmpd="sng" algn="ctr">
+                      <a:solidFill>
+                        <a:srgbClr val="DDDDDD"/>
+                      </a:solidFill>
+                      <a:prstDash val="solid"/>
+                      <a:round/>
+                      <a:headEnd type="none" w="med" len="med"/>
+                      <a:tailEnd type="none" w="med" len="med"/>
+                    </a:lnR>
+                    <a:lnT w="6350" cap="flat" cmpd="sng" algn="ctr">
+                      <a:solidFill>
+                        <a:srgbClr val="DDDDDD"/>
+                      </a:solidFill>
+                      <a:prstDash val="solid"/>
+                      <a:round/>
+                      <a:headEnd type="none" w="med" len="med"/>
+                      <a:tailEnd type="none" w="med" len="med"/>
+                    </a:lnT>
+                    <a:lnB w="6350" cap="flat" cmpd="sng" algn="ctr">
+                      <a:solidFill>
+                        <a:srgbClr val="DDDDDD"/>
+                      </a:solidFill>
+                      <a:prstDash val="solid"/>
+                      <a:round/>
+                      <a:headEnd type="none" w="med" len="med"/>
+                      <a:tailEnd type="none" w="med" len="med"/>
+                    </a:lnB>
+                    <a:solidFill>
+                      <a:srgbClr val="F8F9FA"/>
+                    </a:solidFill>
+                  </a:tcPr>
+                </a:tc>
+                <a:tc>
+                  <a:txBody>
+                    <a:bodyPr/>
+                    <a:lstStyle/>
+                    <a:p>
+                      <a:pPr indent="0" marL="0">
+                        <a:buNone/>
+                      </a:pPr>
+                      <a:r>
+                        <a:rPr lang="en-US" sz="1100" dirty="0">
+                          <a:solidFill>
+                            <a:srgbClr val="1A1A2E"/>
+                          </a:solidFill>
+                        </a:rPr>
+                        <a:t>2개</a:t>
+                      </a:r>
+                      <a:endParaRPr lang="en-US" sz="1100" dirty="0"/>
+                    </a:p>
+                  </a:txBody>
+                  <a:tcPr marL="101600" marR="101600" marT="50800" marB="50800">
+                    <a:lnL w="6350" cap="flat" cmpd="sng" algn="ctr">
+                      <a:solidFill>
+                        <a:srgbClr val="DDDDDD"/>
+                      </a:solidFill>
+                      <a:prstDash val="solid"/>
+                      <a:round/>
+                      <a:headEnd type="none" w="med" len="med"/>
+                      <a:tailEnd type="none" w="med" len="med"/>
+                    </a:lnL>
+                    <a:lnR w="6350" cap="flat" cmpd="sng" algn="ctr">
+                      <a:solidFill>
+                        <a:srgbClr val="DDDDDD"/>
+                      </a:solidFill>
+                      <a:prstDash val="solid"/>
+                      <a:round/>
+                      <a:headEnd type="none" w="med" len="med"/>
+                      <a:tailEnd type="none" w="med" len="med"/>
+                    </a:lnR>
+                    <a:lnT w="6350" cap="flat" cmpd="sng" algn="ctr">
+                      <a:solidFill>
+                        <a:srgbClr val="DDDDDD"/>
+                      </a:solidFill>
+                      <a:prstDash val="solid"/>
+                      <a:round/>
+                      <a:headEnd type="none" w="med" len="med"/>
+                      <a:tailEnd type="none" w="med" len="med"/>
+                    </a:lnT>
+                    <a:lnB w="6350" cap="flat" cmpd="sng" algn="ctr">
+                      <a:solidFill>
+                        <a:srgbClr val="DDDDDD"/>
+                      </a:solidFill>
+                      <a:prstDash val="solid"/>
+                      <a:round/>
+                      <a:headEnd type="none" w="med" len="med"/>
+                      <a:tailEnd type="none" w="med" len="med"/>
+                    </a:lnB>
+                    <a:solidFill>
+                      <a:srgbClr val="F8F9FA"/>
+                    </a:solidFill>
+                  </a:tcPr>
+                </a:tc>
+                <a:tc>
+                  <a:txBody>
+                    <a:bodyPr/>
+                    <a:lstStyle/>
+                    <a:p>
+                      <a:pPr indent="0" marL="0">
+                        <a:buNone/>
+                      </a:pPr>
+                      <a:r>
+                        <a:rPr lang="en-US" sz="1100" dirty="0">
+                          <a:solidFill>
+                            <a:srgbClr val="1A1A2E"/>
+                          </a:solidFill>
+                        </a:rPr>
+                        <a:t>보안 전문가 대체</a:t>
+                      </a:r>
+                      <a:endParaRPr lang="en-US" sz="1100" dirty="0"/>
+                    </a:p>
+                  </a:txBody>
+                  <a:tcPr marL="101600" marR="101600" marT="50800" marB="50800">
+                    <a:lnL w="6350" cap="flat" cmpd="sng" algn="ctr">
+                      <a:solidFill>
+                        <a:srgbClr val="DDDDDD"/>
+                      </a:solidFill>
+                      <a:prstDash val="solid"/>
+                      <a:round/>
+                      <a:headEnd type="none" w="med" len="med"/>
+                      <a:tailEnd type="none" w="med" len="med"/>
+                    </a:lnL>
+                    <a:lnR w="6350" cap="flat" cmpd="sng" algn="ctr">
+                      <a:solidFill>
+                        <a:srgbClr val="DDDDDD"/>
+                      </a:solidFill>
+                      <a:prstDash val="solid"/>
+                      <a:round/>
+                      <a:headEnd type="none" w="med" len="med"/>
+                      <a:tailEnd type="none" w="med" len="med"/>
+                    </a:lnR>
+                    <a:lnT w="6350" cap="flat" cmpd="sng" algn="ctr">
+                      <a:solidFill>
+                        <a:srgbClr val="DDDDDD"/>
+                      </a:solidFill>
+                      <a:prstDash val="solid"/>
+                      <a:round/>
+                      <a:headEnd type="none" w="med" len="med"/>
+                      <a:tailEnd type="none" w="med" len="med"/>
+                    </a:lnT>
+                    <a:lnB w="6350" cap="flat" cmpd="sng" algn="ctr">
+                      <a:solidFill>
+                        <a:srgbClr val="DDDDDD"/>
+                      </a:solidFill>
+                      <a:prstDash val="solid"/>
+                      <a:round/>
+                      <a:headEnd type="none" w="med" len="med"/>
+                      <a:tailEnd type="none" w="med" len="med"/>
+                    </a:lnB>
+                    <a:solidFill>
+                      <a:srgbClr val="F8F9FA"/>
+                    </a:solidFill>
+                  </a:tcPr>
+                </a:tc>
+              </a:tr>
+            </a:tbl>
+          </a:graphicData>
+        </a:graphic>
+      </p:graphicFrame>
+      <p:sp>
+        <p:nvSpPr>
+          <p:cNvPr id="5" name="Text 2"/>
+          <p:cNvSpPr/>
+          <p:nvPr/>
+        </p:nvSpPr>
+        <p:spPr>
+          <a:xfrm>
+            <a:off x="6400800" y="1280160"/>
+            <a:ext cx="5029200" cy="0"/>
+          </a:xfrm>
+          <a:prstGeom prst="rect">
+            <a:avLst/>
+          </a:prstGeom>
+          <a:noFill/>
+          <a:ln/>
+        </p:spPr>
+        <p:txBody>
+          <a:bodyPr wrap="square" rtlCol="0" anchor="ctr"/>
+          <a:lstStyle/>
+          <a:p>
+            <a:pPr indent="0" marL="0">
+              <a:buNone/>
+            </a:pPr>
+            <a:r>
+              <a:rPr lang="en-US" sz="1600" b="1" dirty="0">
+                <a:solidFill>
+                  <a:srgbClr val="1E2761"/>
+                </a:solidFill>
+                <a:latin typeface="Arial" pitchFamily="34" charset="0"/>
+                <a:ea typeface="Arial" pitchFamily="34" charset="-122"/>
+                <a:cs typeface="Arial" pitchFamily="34" charset="-120"/>
+              </a:rPr>
+              <a:t>인건비 절감</a:t>
+            </a:r>
+            <a:endParaRPr lang="en-US" sz="1600" dirty="0"/>
+          </a:p>
+        </p:txBody>
+      </p:sp>
+      <p:graphicFrame>
+        <p:nvGraphicFramePr>
+          <p:cNvPr id="17" name="Table 1"/>
+          <p:cNvGraphicFramePr>
+            <a:graphicFrameLocks noGrp="1"/>
+          </p:cNvGraphicFramePr>
+          <p:nvPr>
+            <p:extLst>
+              <p:ext uri="{D42A27DB-BD31-4B8C-83A1-F6EECF244321}">
+                <p14:modId xmlns:p14="http://schemas.microsoft.com/office/powerpoint/2010/main" val="1579011935"/>
+              </p:ext>
+            </p:extLst>
+          </p:nvPr>
+        </p:nvGraphicFramePr>
+        <p:xfrm>
+          <a:off x="6400800" y="1645920"/>
+          <a:ext cx="5029200" cy="914400"/>
+        </p:xfrm>
+        <a:graphic>
+          <a:graphicData uri="http://schemas.openxmlformats.org/drawingml/2006/table">
+            <a:tbl>
+              <a:tblPr/>
+              <a:tblGrid>
+                <a:gridCol w="2286000"/>
+                <a:gridCol w="2743200"/>
+              </a:tblGrid>
+              <a:tr h="0">
+                <a:tc>
+                  <a:txBody>
+                    <a:bodyPr/>
+                    <a:lstStyle/>
+                    <a:p>
+                      <a:pPr indent="0" marL="0">
+                        <a:buNone/>
+                      </a:pPr>
+                      <a:r>
+                        <a:rPr lang="en-US" sz="1100" b="1" dirty="0">
+                          <a:solidFill>
+                            <a:srgbClr val="FFFFFF"/>
+                          </a:solidFill>
+                        </a:rPr>
+                        <a:t>항목</a:t>
+                      </a:r>
+                      <a:endParaRPr lang="en-US" sz="1100" dirty="0"/>
+                    </a:p>
+                  </a:txBody>
+                  <a:tcPr marL="101600" marR="101600" marT="50800" marB="50800">
+                    <a:lnL w="6350" cap="flat" cmpd="sng" algn="ctr">
+                      <a:solidFill>
+                        <a:srgbClr val="DDDDDD"/>
+                      </a:solidFill>
+                      <a:prstDash val="solid"/>
+                      <a:round/>
+                      <a:headEnd type="none" w="med" len="med"/>
+                      <a:tailEnd type="none" w="med" len="med"/>
+                    </a:lnL>
+                    <a:lnR w="6350" cap="flat" cmpd="sng" algn="ctr">
+                      <a:solidFill>
+                        <a:srgbClr val="DDDDDD"/>
+                      </a:solidFill>
+                      <a:prstDash val="solid"/>
+                      <a:round/>
+                      <a:headEnd type="none" w="med" len="med"/>
+                      <a:tailEnd type="none" w="med" len="med"/>
+                    </a:lnR>
+                    <a:lnT w="6350" cap="flat" cmpd="sng" algn="ctr">
+                      <a:solidFill>
+                        <a:srgbClr val="DDDDDD"/>
+                      </a:solidFill>
+                      <a:prstDash val="solid"/>
+                      <a:round/>
+                      <a:headEnd type="none" w="med" len="med"/>
+                      <a:tailEnd type="none" w="med" len="med"/>
+                    </a:lnT>
+                    <a:lnB w="6350" cap="flat" cmpd="sng" algn="ctr">
+                      <a:solidFill>
+                        <a:srgbClr val="DDDDDD"/>
+                      </a:solidFill>
+                      <a:prstDash val="solid"/>
+                      <a:round/>
+                      <a:headEnd type="none" w="med" len="med"/>
+                      <a:tailEnd type="none" w="med" len="med"/>
+                    </a:lnB>
+                    <a:solidFill>
+                      <a:srgbClr val="2ECC71"/>
+                    </a:solidFill>
+                  </a:tcPr>
+                </a:tc>
+                <a:tc>
+                  <a:txBody>
+                    <a:bodyPr/>
+                    <a:lstStyle/>
+                    <a:p>
+                      <a:pPr indent="0" marL="0">
+                        <a:buNone/>
+                      </a:pPr>
+                      <a:r>
+                        <a:rPr lang="en-US" sz="1100" b="1" dirty="0">
+                          <a:solidFill>
+                            <a:srgbClr val="FFFFFF"/>
+                          </a:solidFill>
+                        </a:rPr>
+                        <a:t>금액</a:t>
+                      </a:r>
+                      <a:endParaRPr lang="en-US" sz="1100" dirty="0"/>
+                    </a:p>
+                  </a:txBody>
+                  <a:tcPr marL="101600" marR="101600" marT="50800" marB="50800">
+                    <a:lnL w="6350" cap="flat" cmpd="sng" algn="ctr">
+                      <a:solidFill>
+                        <a:srgbClr val="DDDDDD"/>
+                      </a:solidFill>
+                      <a:prstDash val="solid"/>
+                      <a:round/>
+                      <a:headEnd type="none" w="med" len="med"/>
+                      <a:tailEnd type="none" w="med" len="med"/>
+                    </a:lnL>
+                    <a:lnR w="6350" cap="flat" cmpd="sng" algn="ctr">
+                      <a:solidFill>
+                        <a:srgbClr val="DDDDDD"/>
+                      </a:solidFill>
+                      <a:prstDash val="solid"/>
+                      <a:round/>
+                      <a:headEnd type="none" w="med" len="med"/>
+                      <a:tailEnd type="none" w="med" len="med"/>
+                    </a:lnR>
+                    <a:lnT w="6350" cap="flat" cmpd="sng" algn="ctr">
+                      <a:solidFill>
+                        <a:srgbClr val="DDDDDD"/>
+                      </a:solidFill>
+                      <a:prstDash val="solid"/>
+                      <a:round/>
+                      <a:headEnd type="none" w="med" len="med"/>
+                      <a:tailEnd type="none" w="med" len="med"/>
+                    </a:lnT>
+                    <a:lnB w="6350" cap="flat" cmpd="sng" algn="ctr">
+                      <a:solidFill>
+                        <a:srgbClr val="DDDDDD"/>
+                      </a:solidFill>
+                      <a:prstDash val="solid"/>
+                      <a:round/>
+                      <a:headEnd type="none" w="med" len="med"/>
+                      <a:tailEnd type="none" w="med" len="med"/>
+                    </a:lnB>
+                    <a:solidFill>
+                      <a:srgbClr val="2ECC71"/>
+                    </a:solidFill>
+                  </a:tcPr>
+                </a:tc>
+              </a:tr>
+              <a:tr h="0">
+                <a:tc>
+                  <a:txBody>
+                    <a:bodyPr/>
+                    <a:lstStyle/>
+                    <a:p>
+                      <a:pPr indent="0" marL="0">
+                        <a:buNone/>
+                      </a:pPr>
+                      <a:r>
+                        <a:rPr lang="en-US" sz="1100" dirty="0">
+                          <a:solidFill>
+                            <a:srgbClr val="1A1A2E"/>
+                          </a:solidFill>
+                        </a:rPr>
+                        <a:t>일반 스타트업</a:t>
+                      </a:r>
+                      <a:endParaRPr lang="en-US" sz="1100" dirty="0"/>
+                    </a:p>
+                  </a:txBody>
+                  <a:tcPr marL="101600" marR="101600" marT="50800" marB="50800">
                     <a:lnL w="6350" cap="flat" cmpd="sng" algn="ctr">
                       <a:solidFill>
                         <a:srgbClr val="DDDDDD"/>
@@ -13673,12 +15532,75 @@
                             <a:srgbClr val="1A1A2E"/>
                           </a:solidFill>
                         </a:rPr>
-                        <a:t>중간</a:t>
+                        <a:t>월 3,200만원</a:t>
                       </a:r>
                       <a:endParaRPr lang="en-US" sz="1100" dirty="0"/>
                     </a:p>
                   </a:txBody>
-                  <a:tcPr marL="127000" marR="127000" marT="76200" marB="76200">
+                  <a:tcPr marL="101600" marR="101600" marT="50800" marB="50800">
+                    <a:lnL w="6350" cap="flat" cmpd="sng" algn="ctr">
+                      <a:solidFill>
+                        <a:srgbClr val="DDDDDD"/>
+                      </a:solidFill>
+                      <a:prstDash val="solid"/>
+                      <a:round/>
+                      <a:headEnd type="none" w="med" len="med"/>
+                      <a:tailEnd type="none" w="med" len="med"/>
+                    </a:lnL>
+                    <a:lnR w="6350" cap="flat" cmpd="sng" algn="ctr">
+                      <a:solidFill>
+                        <a:srgbClr val="DDDDDD"/>
+                      </a:solidFill>
+                      <a:prstDash val="solid"/>
+                      <a:round/>
+                      <a:headEnd type="none" w="med" len="med"/>
+                      <a:tailEnd type="none" w="med" len="med"/>
+                    </a:lnR>
+                    <a:lnT w="6350" cap="flat" cmpd="sng" algn="ctr">
+                      <a:solidFill>
+                        <a:srgbClr val="DDDDDD"/>
+                      </a:solidFill>
+                      <a:prstDash val="solid"/>
+                      <a:round/>
+                      <a:headEnd type="none" w="med" len="med"/>
+                      <a:tailEnd type="none" w="med" len="med"/>
+                    </a:lnT>
+                    <a:lnB w="6350" cap="flat" cmpd="sng" algn="ctr">
+                      <a:solidFill>
+                        <a:srgbClr val="DDDDDD"/>
+                      </a:solidFill>
+                      <a:prstDash val="solid"/>
+                      <a:round/>
+                      <a:headEnd type="none" w="med" len="med"/>
+                      <a:tailEnd type="none" w="med" len="med"/>
+                    </a:lnB>
+                    <a:solidFill>
+                      <a:srgbClr val="F8F9FA"/>
+                    </a:solidFill>
+                  </a:tcPr>
+                </a:tc>
+              </a:tr>
+              <a:tr h="0">
+                <a:tc>
+                  <a:txBody>
+                    <a:bodyPr/>
+                    <a:lstStyle/>
+                    <a:p>
+                      <a:pPr indent="0" marL="0">
+                        <a:buNone/>
+                      </a:pPr>
+                      <a:r>
+                        <a:rPr lang="en-US" sz="1100" dirty="0">
+                          <a:solidFill>
+                            <a:srgbClr val="1A1A2E"/>
+                          </a:solidFill>
+                        </a:rPr>
+                        <a:t>AI 개발팀</a:t>
+                      </a:r>
+                      <a:endParaRPr lang="en-US" sz="1100" dirty="0"/>
+                    </a:p>
+                  </a:txBody>
+                  <a:tcPr marL="101600" marR="101600" marT="50800" marB="50800">
                     <a:lnL w="6350" cap="flat" cmpd="sng" algn="ctr">
                       <a:solidFill>
                         <a:srgbClr val="DDDDDD"/>
@@ -13729,17 +15651,265 @@
                         <a:buNone/>
                       </a:pPr>
                       <a:r>
+                        <a:rPr lang="en-US" sz="1100" b="1" dirty="0">
+                          <a:solidFill>
+                            <a:srgbClr val="1A1A2E"/>
+                          </a:solidFill>
+                        </a:rPr>
+                        <a:t>월 ~20만원</a:t>
+                      </a:r>
+                      <a:endParaRPr lang="en-US" sz="1100" dirty="0"/>
+                    </a:p>
+                  </a:txBody>
+                  <a:tcPr marL="101600" marR="101600" marT="50800" marB="50800">
+                    <a:lnL w="6350" cap="flat" cmpd="sng" algn="ctr">
+                      <a:solidFill>
+                        <a:srgbClr val="DDDDDD"/>
+                      </a:solidFill>
+                      <a:prstDash val="solid"/>
+                      <a:round/>
+                      <a:headEnd type="none" w="med" len="med"/>
+                      <a:tailEnd type="none" w="med" len="med"/>
+                    </a:lnL>
+                    <a:lnR w="6350" cap="flat" cmpd="sng" algn="ctr">
+                      <a:solidFill>
+                        <a:srgbClr val="DDDDDD"/>
+                      </a:solidFill>
+                      <a:prstDash val="solid"/>
+                      <a:round/>
+                      <a:headEnd type="none" w="med" len="med"/>
+                      <a:tailEnd type="none" w="med" len="med"/>
+                    </a:lnR>
+                    <a:lnT w="6350" cap="flat" cmpd="sng" algn="ctr">
+                      <a:solidFill>
+                        <a:srgbClr val="DDDDDD"/>
+                      </a:solidFill>
+                      <a:prstDash val="solid"/>
+                      <a:round/>
+                      <a:headEnd type="none" w="med" len="med"/>
+                      <a:tailEnd type="none" w="med" len="med"/>
+                    </a:lnT>
+                    <a:lnB w="6350" cap="flat" cmpd="sng" algn="ctr">
+                      <a:solidFill>
+                        <a:srgbClr val="DDDDDD"/>
+                      </a:solidFill>
+                      <a:prstDash val="solid"/>
+                      <a:round/>
+                      <a:headEnd type="none" w="med" len="med"/>
+                      <a:tailEnd type="none" w="med" len="med"/>
+                    </a:lnB>
+                    <a:solidFill>
+                      <a:srgbClr val="F8F9FA"/>
+                    </a:solidFill>
+                  </a:tcPr>
+                </a:tc>
+              </a:tr>
+              <a:tr h="0">
+                <a:tc>
+                  <a:txBody>
+                    <a:bodyPr/>
+                    <a:lstStyle/>
+                    <a:p>
+                      <a:pPr indent="0" marL="0">
+                        <a:buNone/>
+                      </a:pPr>
+                      <a:r>
                         <a:rPr lang="en-US" sz="1100" dirty="0">
                           <a:solidFill>
                             <a:srgbClr val="1A1A2E"/>
                           </a:solidFill>
                         </a:rPr>
-                        <a:t>STO 구조로 투기 제한 + 소각 메커니즘</a:t>
+                        <a:t>절감율</a:t>
                       </a:r>
                       <a:endParaRPr lang="en-US" sz="1100" dirty="0"/>
                     </a:p>
                   </a:txBody>
-                  <a:tcPr marL="127000" marR="127000" marT="76200" marB="76200">
+                  <a:tcPr marL="101600" marR="101600" marT="50800" marB="50800">
+                    <a:lnL w="6350" cap="flat" cmpd="sng" algn="ctr">
+                      <a:solidFill>
+                        <a:srgbClr val="DDDDDD"/>
+                      </a:solidFill>
+                      <a:prstDash val="solid"/>
+                      <a:round/>
+                      <a:headEnd type="none" w="med" len="med"/>
+                      <a:tailEnd type="none" w="med" len="med"/>
+                    </a:lnL>
+                    <a:lnR w="6350" cap="flat" cmpd="sng" algn="ctr">
+                      <a:solidFill>
+                        <a:srgbClr val="DDDDDD"/>
+                      </a:solidFill>
+                      <a:prstDash val="solid"/>
+                      <a:round/>
+                      <a:headEnd type="none" w="med" len="med"/>
+                      <a:tailEnd type="none" w="med" len="med"/>
+                    </a:lnR>
+                    <a:lnT w="6350" cap="flat" cmpd="sng" algn="ctr">
+                      <a:solidFill>
+                        <a:srgbClr val="DDDDDD"/>
+                      </a:solidFill>
+                      <a:prstDash val="solid"/>
+                      <a:round/>
+                      <a:headEnd type="none" w="med" len="med"/>
+                      <a:tailEnd type="none" w="med" len="med"/>
+                    </a:lnT>
+                    <a:lnB w="6350" cap="flat" cmpd="sng" algn="ctr">
+                      <a:solidFill>
+                        <a:srgbClr val="DDDDDD"/>
+                      </a:solidFill>
+                      <a:prstDash val="solid"/>
+                      <a:round/>
+                      <a:headEnd type="none" w="med" len="med"/>
+                      <a:tailEnd type="none" w="med" len="med"/>
+                    </a:lnB>
+                    <a:solidFill>
+                      <a:srgbClr val="F8F9FA"/>
+                    </a:solidFill>
+                  </a:tcPr>
+                </a:tc>
+                <a:tc>
+                  <a:txBody>
+                    <a:bodyPr/>
+                    <a:lstStyle/>
+                    <a:p>
+                      <a:pPr indent="0" marL="0">
+                        <a:buNone/>
+                      </a:pPr>
+                      <a:r>
+                        <a:rPr lang="en-US" sz="1100" b="1" dirty="0">
+                          <a:solidFill>
+                            <a:srgbClr val="1A1A2E"/>
+                          </a:solidFill>
+                        </a:rPr>
+                        <a:t>99.4%</a:t>
+                      </a:r>
+                      <a:endParaRPr lang="en-US" sz="1100" dirty="0"/>
+                    </a:p>
+                  </a:txBody>
+                  <a:tcPr marL="101600" marR="101600" marT="50800" marB="50800">
+                    <a:lnL w="6350" cap="flat" cmpd="sng" algn="ctr">
+                      <a:solidFill>
+                        <a:srgbClr val="DDDDDD"/>
+                      </a:solidFill>
+                      <a:prstDash val="solid"/>
+                      <a:round/>
+                      <a:headEnd type="none" w="med" len="med"/>
+                      <a:tailEnd type="none" w="med" len="med"/>
+                    </a:lnL>
+                    <a:lnR w="6350" cap="flat" cmpd="sng" algn="ctr">
+                      <a:solidFill>
+                        <a:srgbClr val="DDDDDD"/>
+                      </a:solidFill>
+                      <a:prstDash val="solid"/>
+                      <a:round/>
+                      <a:headEnd type="none" w="med" len="med"/>
+                      <a:tailEnd type="none" w="med" len="med"/>
+                    </a:lnR>
+                    <a:lnT w="6350" cap="flat" cmpd="sng" algn="ctr">
+                      <a:solidFill>
+                        <a:srgbClr val="DDDDDD"/>
+                      </a:solidFill>
+                      <a:prstDash val="solid"/>
+                      <a:round/>
+                      <a:headEnd type="none" w="med" len="med"/>
+                      <a:tailEnd type="none" w="med" len="med"/>
+                    </a:lnT>
+                    <a:lnB w="6350" cap="flat" cmpd="sng" algn="ctr">
+                      <a:solidFill>
+                        <a:srgbClr val="DDDDDD"/>
+                      </a:solidFill>
+                      <a:prstDash val="solid"/>
+                      <a:round/>
+                      <a:headEnd type="none" w="med" len="med"/>
+                      <a:tailEnd type="none" w="med" len="med"/>
+                    </a:lnB>
+                    <a:solidFill>
+                      <a:srgbClr val="F8F9FA"/>
+                    </a:solidFill>
+                  </a:tcPr>
+                </a:tc>
+              </a:tr>
+              <a:tr h="0">
+                <a:tc>
+                  <a:txBody>
+                    <a:bodyPr/>
+                    <a:lstStyle/>
+                    <a:p>
+                      <a:pPr indent="0" marL="0">
+                        <a:buNone/>
+                      </a:pPr>
+                      <a:r>
+                        <a:rPr lang="en-US" sz="1100" dirty="0">
+                          <a:solidFill>
+                            <a:srgbClr val="1A1A2E"/>
+                          </a:solidFill>
+                        </a:rPr>
+                        <a:t>연간 절감</a:t>
+                      </a:r>
+                      <a:endParaRPr lang="en-US" sz="1100" dirty="0"/>
+                    </a:p>
+                  </a:txBody>
+                  <a:tcPr marL="101600" marR="101600" marT="50800" marB="50800">
+                    <a:lnL w="6350" cap="flat" cmpd="sng" algn="ctr">
+                      <a:solidFill>
+                        <a:srgbClr val="DDDDDD"/>
+                      </a:solidFill>
+                      <a:prstDash val="solid"/>
+                      <a:round/>
+                      <a:headEnd type="none" w="med" len="med"/>
+                      <a:tailEnd type="none" w="med" len="med"/>
+                    </a:lnL>
+                    <a:lnR w="6350" cap="flat" cmpd="sng" algn="ctr">
+                      <a:solidFill>
+                        <a:srgbClr val="DDDDDD"/>
+                      </a:solidFill>
+                      <a:prstDash val="solid"/>
+                      <a:round/>
+                      <a:headEnd type="none" w="med" len="med"/>
+                      <a:tailEnd type="none" w="med" len="med"/>
+                    </a:lnR>
+                    <a:lnT w="6350" cap="flat" cmpd="sng" algn="ctr">
+                      <a:solidFill>
+                        <a:srgbClr val="DDDDDD"/>
+                      </a:solidFill>
+                      <a:prstDash val="solid"/>
+                      <a:round/>
+                      <a:headEnd type="none" w="med" len="med"/>
+                      <a:tailEnd type="none" w="med" len="med"/>
+                    </a:lnT>
+                    <a:lnB w="6350" cap="flat" cmpd="sng" algn="ctr">
+                      <a:solidFill>
+                        <a:srgbClr val="DDDDDD"/>
+                      </a:solidFill>
+                      <a:prstDash val="solid"/>
+                      <a:round/>
+                      <a:headEnd type="none" w="med" len="med"/>
+                      <a:tailEnd type="none" w="med" len="med"/>
+                    </a:lnB>
+                    <a:solidFill>
+                      <a:srgbClr val="F8F9FA"/>
+                    </a:solidFill>
+                  </a:tcPr>
+                </a:tc>
+                <a:tc>
+                  <a:txBody>
+                    <a:bodyPr/>
+                    <a:lstStyle/>
+                    <a:p>
+                      <a:pPr indent="0" marL="0">
+                        <a:buNone/>
+                      </a:pPr>
+                      <a:r>
+                        <a:rPr lang="en-US" sz="1100" b="1" dirty="0">
+                          <a:solidFill>
+                            <a:srgbClr val="1A1A2E"/>
+                          </a:solidFill>
+                        </a:rPr>
+                        <a:t>3.6억원</a:t>
+                      </a:r>
+                      <a:endParaRPr lang="en-US" sz="1100" dirty="0"/>
+                    </a:p>
+                  </a:txBody>
+                  <a:tcPr marL="101600" marR="101600" marT="50800" marB="50800">
                     <a:lnL w="6350" cap="flat" cmpd="sng" algn="ctr">
                       <a:solidFill>
                         <a:srgbClr val="DDDDDD"/>
@@ -13786,6 +15956,423 @@
           </a:graphicData>
         </a:graphic>
       </p:graphicFrame>
+      <p:sp>
+        <p:nvSpPr>
+          <p:cNvPr id="7" name="Shape 3"/>
+          <p:cNvSpPr/>
+          <p:nvPr/>
+        </p:nvSpPr>
+        <p:spPr>
+          <a:xfrm>
+            <a:off x="731520" y="4572000"/>
+            <a:ext cx="3200400" cy="1645920"/>
+          </a:xfrm>
+          <a:prstGeom prst="roundRect">
+            <a:avLst>
+              <a:gd name="adj" fmla="val 8333"/>
+            </a:avLst>
+          </a:prstGeom>
+          <a:solidFill>
+            <a:srgbClr val="1E2761"/>
+          </a:solidFill>
+          <a:ln/>
+        </p:spPr>
+      </p:sp>
+      <p:sp>
+        <p:nvSpPr>
+          <p:cNvPr id="8" name="Text 4"/>
+          <p:cNvSpPr/>
+          <p:nvPr/>
+        </p:nvSpPr>
+        <p:spPr>
+          <a:xfrm>
+            <a:off x="731520" y="4663440"/>
+            <a:ext cx="3200400" cy="0"/>
+          </a:xfrm>
+          <a:prstGeom prst="rect">
+            <a:avLst/>
+          </a:prstGeom>
+          <a:noFill/>
+          <a:ln/>
+        </p:spPr>
+        <p:txBody>
+          <a:bodyPr wrap="square" rtlCol="0" anchor="ctr"/>
+          <a:lstStyle/>
+          <a:p>
+            <a:pPr algn="ctr" indent="0" marL="0">
+              <a:buNone/>
+            </a:pPr>
+            <a:r>
+              <a:rPr lang="en-US" sz="1200" dirty="0">
+                <a:solidFill>
+                  <a:srgbClr val="95A5A6"/>
+                </a:solidFill>
+                <a:latin typeface="Arial" pitchFamily="34" charset="0"/>
+                <a:ea typeface="Arial" pitchFamily="34" charset="-122"/>
+                <a:cs typeface="Arial" pitchFamily="34" charset="-120"/>
+              </a:rPr>
+              <a:t>개발 속도</a:t>
+            </a:r>
+            <a:endParaRPr lang="en-US" sz="1200" dirty="0"/>
+          </a:p>
+        </p:txBody>
+      </p:sp>
+      <p:sp>
+        <p:nvSpPr>
+          <p:cNvPr id="9" name="Text 5"/>
+          <p:cNvSpPr/>
+          <p:nvPr/>
+        </p:nvSpPr>
+        <p:spPr>
+          <a:xfrm>
+            <a:off x="731520" y="5029200"/>
+            <a:ext cx="3200400" cy="0"/>
+          </a:xfrm>
+          <a:prstGeom prst="rect">
+            <a:avLst/>
+          </a:prstGeom>
+          <a:noFill/>
+          <a:ln/>
+        </p:spPr>
+        <p:txBody>
+          <a:bodyPr wrap="square" rtlCol="0" anchor="ctr"/>
+          <a:lstStyle/>
+          <a:p>
+            <a:pPr algn="ctr" indent="0" marL="0">
+              <a:buNone/>
+            </a:pPr>
+            <a:r>
+              <a:rPr lang="en-US" sz="3200" b="1" dirty="0">
+                <a:solidFill>
+                  <a:srgbClr val="FFFFFF"/>
+                </a:solidFill>
+                <a:latin typeface="Arial Black" pitchFamily="34" charset="0"/>
+                <a:ea typeface="Arial Black" pitchFamily="34" charset="-122"/>
+                <a:cs typeface="Arial Black" pitchFamily="34" charset="-120"/>
+              </a:rPr>
+              <a:t>33% 단축</a:t>
+            </a:r>
+            <a:endParaRPr lang="en-US" sz="3200" dirty="0"/>
+          </a:p>
+        </p:txBody>
+      </p:sp>
+      <p:sp>
+        <p:nvSpPr>
+          <p:cNvPr id="10" name="Text 6"/>
+          <p:cNvSpPr/>
+          <p:nvPr/>
+        </p:nvSpPr>
+        <p:spPr>
+          <a:xfrm>
+            <a:off x="731520" y="5669280"/>
+            <a:ext cx="3200400" cy="0"/>
+          </a:xfrm>
+          <a:prstGeom prst="rect">
+            <a:avLst/>
+          </a:prstGeom>
+          <a:noFill/>
+          <a:ln/>
+        </p:spPr>
+        <p:txBody>
+          <a:bodyPr wrap="square" rtlCol="0" anchor="ctr"/>
+          <a:lstStyle/>
+          <a:p>
+            <a:pPr algn="ctr" indent="0" marL="0">
+              <a:buNone/>
+            </a:pPr>
+            <a:r>
+              <a:rPr lang="en-US" sz="1400" dirty="0">
+                <a:solidFill>
+                  <a:srgbClr val="2ECC71"/>
+                </a:solidFill>
+                <a:latin typeface="Arial" pitchFamily="34" charset="0"/>
+                <a:ea typeface="Arial" pitchFamily="34" charset="-122"/>
+                <a:cs typeface="Arial" pitchFamily="34" charset="-120"/>
+              </a:rPr>
+              <a:t>38주 → 25.5주</a:t>
+            </a:r>
+            <a:endParaRPr lang="en-US" sz="1400" dirty="0"/>
+          </a:p>
+        </p:txBody>
+      </p:sp>
+      <p:sp>
+        <p:nvSpPr>
+          <p:cNvPr id="11" name="Shape 7"/>
+          <p:cNvSpPr/>
+          <p:nvPr/>
+        </p:nvSpPr>
+        <p:spPr>
+          <a:xfrm>
+            <a:off x="4572000" y="4572000"/>
+            <a:ext cx="3200400" cy="1645920"/>
+          </a:xfrm>
+          <a:prstGeom prst="roundRect">
+            <a:avLst>
+              <a:gd name="adj" fmla="val 8333"/>
+            </a:avLst>
+          </a:prstGeom>
+          <a:solidFill>
+            <a:srgbClr val="1E2761"/>
+          </a:solidFill>
+          <a:ln/>
+        </p:spPr>
+      </p:sp>
+      <p:sp>
+        <p:nvSpPr>
+          <p:cNvPr id="12" name="Text 8"/>
+          <p:cNvSpPr/>
+          <p:nvPr/>
+        </p:nvSpPr>
+        <p:spPr>
+          <a:xfrm>
+            <a:off x="4572000" y="4663440"/>
+            <a:ext cx="3200400" cy="0"/>
+          </a:xfrm>
+          <a:prstGeom prst="rect">
+            <a:avLst/>
+          </a:prstGeom>
+          <a:noFill/>
+          <a:ln/>
+        </p:spPr>
+        <p:txBody>
+          <a:bodyPr wrap="square" rtlCol="0" anchor="ctr"/>
+          <a:lstStyle/>
+          <a:p>
+            <a:pPr algn="ctr" indent="0" marL="0">
+              <a:buNone/>
+            </a:pPr>
+            <a:r>
+              <a:rPr lang="en-US" sz="1200" dirty="0">
+                <a:solidFill>
+                  <a:srgbClr val="95A5A6"/>
+                </a:solidFill>
+                <a:latin typeface="Arial" pitchFamily="34" charset="0"/>
+                <a:ea typeface="Arial" pitchFamily="34" charset="-122"/>
+                <a:cs typeface="Arial" pitchFamily="34" charset="-120"/>
+              </a:rPr>
+              <a:t>QA 자동화</a:t>
+            </a:r>
+            <a:endParaRPr lang="en-US" sz="1200" dirty="0"/>
+          </a:p>
+        </p:txBody>
+      </p:sp>
+      <p:sp>
+        <p:nvSpPr>
+          <p:cNvPr id="13" name="Text 9"/>
+          <p:cNvSpPr/>
+          <p:nvPr/>
+        </p:nvSpPr>
+        <p:spPr>
+          <a:xfrm>
+            <a:off x="4572000" y="5029200"/>
+            <a:ext cx="3200400" cy="0"/>
+          </a:xfrm>
+          <a:prstGeom prst="rect">
+            <a:avLst/>
+          </a:prstGeom>
+          <a:noFill/>
+          <a:ln/>
+        </p:spPr>
+        <p:txBody>
+          <a:bodyPr wrap="square" rtlCol="0" anchor="ctr"/>
+          <a:lstStyle/>
+          <a:p>
+            <a:pPr algn="ctr" indent="0" marL="0">
+              <a:buNone/>
+            </a:pPr>
+            <a:r>
+              <a:rPr lang="en-US" sz="3200" b="1" dirty="0">
+                <a:solidFill>
+                  <a:srgbClr val="FFFFFF"/>
+                </a:solidFill>
+                <a:latin typeface="Arial Black" pitchFamily="34" charset="0"/>
+                <a:ea typeface="Arial Black" pitchFamily="34" charset="-122"/>
+                <a:cs typeface="Arial Black" pitchFamily="34" charset="-120"/>
+              </a:rPr>
+              <a:t>16개 에이전트</a:t>
+            </a:r>
+            <a:endParaRPr lang="en-US" sz="3200" dirty="0"/>
+          </a:p>
+        </p:txBody>
+      </p:sp>
+      <p:sp>
+        <p:nvSpPr>
+          <p:cNvPr id="14" name="Text 10"/>
+          <p:cNvSpPr/>
+          <p:nvPr/>
+        </p:nvSpPr>
+        <p:spPr>
+          <a:xfrm>
+            <a:off x="4572000" y="5669280"/>
+            <a:ext cx="3200400" cy="0"/>
+          </a:xfrm>
+          <a:prstGeom prst="rect">
+            <a:avLst/>
+          </a:prstGeom>
+          <a:noFill/>
+          <a:ln/>
+        </p:spPr>
+        <p:txBody>
+          <a:bodyPr wrap="square" rtlCol="0" anchor="ctr"/>
+          <a:lstStyle/>
+          <a:p>
+            <a:pPr algn="ctr" indent="0" marL="0">
+              <a:buNone/>
+            </a:pPr>
+            <a:r>
+              <a:rPr lang="en-US" sz="1400" dirty="0">
+                <a:solidFill>
+                  <a:srgbClr val="2ECC71"/>
+                </a:solidFill>
+                <a:latin typeface="Arial" pitchFamily="34" charset="0"/>
+                <a:ea typeface="Arial" pitchFamily="34" charset="-122"/>
+                <a:cs typeface="Arial" pitchFamily="34" charset="-120"/>
+              </a:rPr>
+              <a:t>84% 버그 발견율</a:t>
+            </a:r>
+            <a:endParaRPr lang="en-US" sz="1400" dirty="0"/>
+          </a:p>
+        </p:txBody>
+      </p:sp>
+      <p:sp>
+        <p:nvSpPr>
+          <p:cNvPr id="15" name="Shape 11"/>
+          <p:cNvSpPr/>
+          <p:nvPr/>
+        </p:nvSpPr>
+        <p:spPr>
+          <a:xfrm>
+            <a:off x="8412480" y="4572000"/>
+            <a:ext cx="3200400" cy="1645920"/>
+          </a:xfrm>
+          <a:prstGeom prst="roundRect">
+            <a:avLst>
+              <a:gd name="adj" fmla="val 8333"/>
+            </a:avLst>
+          </a:prstGeom>
+          <a:solidFill>
+            <a:srgbClr val="1E2761"/>
+          </a:solidFill>
+          <a:ln/>
+        </p:spPr>
+      </p:sp>
+      <p:sp>
+        <p:nvSpPr>
+          <p:cNvPr id="16" name="Text 12"/>
+          <p:cNvSpPr/>
+          <p:nvPr/>
+        </p:nvSpPr>
+        <p:spPr>
+          <a:xfrm>
+            <a:off x="8412480" y="4663440"/>
+            <a:ext cx="3200400" cy="0"/>
+          </a:xfrm>
+          <a:prstGeom prst="rect">
+            <a:avLst/>
+          </a:prstGeom>
+          <a:noFill/>
+          <a:ln/>
+        </p:spPr>
+        <p:txBody>
+          <a:bodyPr wrap="square" rtlCol="0" anchor="ctr"/>
+          <a:lstStyle/>
+          <a:p>
+            <a:pPr algn="ctr" indent="0" marL="0">
+              <a:buNone/>
+            </a:pPr>
+            <a:r>
+              <a:rPr lang="en-US" sz="1200" dirty="0">
+                <a:solidFill>
+                  <a:srgbClr val="95A5A6"/>
+                </a:solidFill>
+                <a:latin typeface="Arial" pitchFamily="34" charset="0"/>
+                <a:ea typeface="Arial" pitchFamily="34" charset="-122"/>
+                <a:cs typeface="Arial" pitchFamily="34" charset="-120"/>
+              </a:rPr>
+              <a:t>대표님 역할</a:t>
+            </a:r>
+            <a:endParaRPr lang="en-US" sz="1200" dirty="0"/>
+          </a:p>
+        </p:txBody>
+      </p:sp>
+      <p:sp>
+        <p:nvSpPr>
+          <p:cNvPr id="17" name="Text 13"/>
+          <p:cNvSpPr/>
+          <p:nvPr/>
+        </p:nvSpPr>
+        <p:spPr>
+          <a:xfrm>
+            <a:off x="8412480" y="5029200"/>
+            <a:ext cx="3200400" cy="0"/>
+          </a:xfrm>
+          <a:prstGeom prst="rect">
+            <a:avLst/>
+          </a:prstGeom>
+          <a:noFill/>
+          <a:ln/>
+        </p:spPr>
+        <p:txBody>
+          <a:bodyPr wrap="square" rtlCol="0" anchor="ctr"/>
+          <a:lstStyle/>
+          <a:p>
+            <a:pPr algn="ctr" indent="0" marL="0">
+              <a:buNone/>
+            </a:pPr>
+            <a:r>
+              <a:rPr lang="en-US" sz="3200" b="1" dirty="0">
+                <a:solidFill>
+                  <a:srgbClr val="FFFFFF"/>
+                </a:solidFill>
+                <a:latin typeface="Arial Black" pitchFamily="34" charset="0"/>
+                <a:ea typeface="Arial Black" pitchFamily="34" charset="-122"/>
+                <a:cs typeface="Arial Black" pitchFamily="34" charset="-120"/>
+              </a:rPr>
+              <a:t>의사결정자</a:t>
+            </a:r>
+            <a:endParaRPr lang="en-US" sz="3200" dirty="0"/>
+          </a:p>
+        </p:txBody>
+      </p:sp>
+      <p:sp>
+        <p:nvSpPr>
+          <p:cNvPr id="18" name="Text 14"/>
+          <p:cNvSpPr/>
+          <p:nvPr/>
+        </p:nvSpPr>
+        <p:spPr>
+          <a:xfrm>
+            <a:off x="8412480" y="5669280"/>
+            <a:ext cx="3200400" cy="0"/>
+          </a:xfrm>
+          <a:prstGeom prst="rect">
+            <a:avLst/>
+          </a:prstGeom>
+          <a:noFill/>
+          <a:ln/>
+        </p:spPr>
+        <p:txBody>
+          <a:bodyPr wrap="square" rtlCol="0" anchor="ctr"/>
+          <a:lstStyle/>
+          <a:p>
+            <a:pPr algn="ctr" indent="0" marL="0">
+              <a:buNone/>
+            </a:pPr>
+            <a:r>
+              <a:rPr lang="en-US" sz="1400" dirty="0">
+                <a:solidFill>
+                  <a:srgbClr val="CADCFC"/>
+                </a:solidFill>
+                <a:latin typeface="Arial" pitchFamily="34" charset="0"/>
+                <a:ea typeface="Arial" pitchFamily="34" charset="-122"/>
+                <a:cs typeface="Arial" pitchFamily="34" charset="-120"/>
+              </a:rPr>
+              <a:t>개발자 → 승인+방향</a:t>
+            </a:r>
+            <a:endParaRPr lang="en-US" sz="1400" dirty="0"/>
+          </a:p>
+        </p:txBody>
+      </p:sp>
     </p:spTree>
   </p:cSld>
   <p:clrMapOvr>
@@ -13851,7 +16438,7 @@
                 <a:ea typeface="Arial Black" pitchFamily="34" charset="-122"/>
                 <a:cs typeface="Arial Black" pitchFamily="34" charset="-120"/>
               </a:rPr>
-              <a:t>추진 일정</a:t>
+              <a:t>리스크 및 대응</a:t>
             </a:r>
             <a:endParaRPr lang="en-US" sz="2800" dirty="0"/>
           </a:p>
@@ -13881,8 +16468,8 @@
               <a:tblPr/>
               <a:tblGrid>
                 <a:gridCol w="2743200"/>
-                <a:gridCol w="3200400"/>
-                <a:gridCol w="5029200"/>
+                <a:gridCol w="1371600"/>
+                <a:gridCol w="6858000"/>
               </a:tblGrid>
               <a:tr h="0">
                 <a:tc>
@@ -13899,12 +16486,12 @@
                             <a:srgbClr val="FFFFFF"/>
                           </a:solidFill>
                         </a:rPr>
-                        <a:t>기간</a:t>
+                        <a:t>리스크</a:t>
                       </a:r>
                       <a:endParaRPr lang="en-US" sz="1200" dirty="0"/>
                     </a:p>
                   </a:txBody>
-                  <a:tcPr marL="152400" marR="152400" marT="101600" marB="101600">
+                  <a:tcPr marL="127000" marR="127000" marT="76200" marB="76200">
                     <a:lnL w="6350" cap="flat" cmpd="sng" algn="ctr">
                       <a:solidFill>
                         <a:srgbClr val="DDDDDD"/>
@@ -13960,12 +16547,12 @@
                             <a:srgbClr val="FFFFFF"/>
                           </a:solidFill>
                         </a:rPr>
-                        <a:t>Phase</a:t>
+                        <a:t>심각도</a:t>
                       </a:r>
                       <a:endParaRPr lang="en-US" sz="1200" dirty="0"/>
                     </a:p>
                   </a:txBody>
-                  <a:tcPr marL="152400" marR="152400" marT="101600" marB="101600">
+                  <a:tcPr marL="127000" marR="127000" marT="76200" marB="76200">
                     <a:lnL w="6350" cap="flat" cmpd="sng" algn="ctr">
                       <a:solidFill>
                         <a:srgbClr val="DDDDDD"/>
@@ -14021,12 +16608,12 @@
                             <a:srgbClr val="FFFFFF"/>
                           </a:solidFill>
                         </a:rPr>
-                        <a:t>핵심 마일스톤</a:t>
+                        <a:t>대응 전략</a:t>
                       </a:r>
                       <a:endParaRPr lang="en-US" sz="1200" dirty="0"/>
                     </a:p>
                   </a:txBody>
-                  <a:tcPr marL="152400" marR="152400" marT="101600" marB="101600">
+                  <a:tcPr marL="127000" marR="127000" marT="76200" marB="76200">
                     <a:lnL w="6350" cap="flat" cmpd="sng" algn="ctr">
                       <a:solidFill>
                         <a:srgbClr val="DDDDDD"/>
@@ -14079,17 +16666,17 @@
                         <a:buNone/>
                       </a:pPr>
                       <a:r>
-                        <a:rPr lang="en-US" sz="1200" dirty="0">
+                        <a:rPr lang="en-US" sz="1100" dirty="0">
                           <a:solidFill>
                             <a:srgbClr val="1A1A2E"/>
                           </a:solidFill>
                         </a:rPr>
-                        <a:t>2026 Q2</a:t>
+                        <a:t>MAU 하락 지속</a:t>
                       </a:r>
-                      <a:endParaRPr lang="en-US" sz="1200" dirty="0"/>
+                      <a:endParaRPr lang="en-US" sz="1100" dirty="0"/>
                     </a:p>
                   </a:txBody>
-                  <a:tcPr marL="152400" marR="152400" marT="101600" marB="101600">
+                  <a:tcPr marL="127000" marR="127000" marT="76200" marB="76200">
                     <a:lnL w="6350" cap="flat" cmpd="sng" algn="ctr">
                       <a:solidFill>
                         <a:srgbClr val="DDDDDD"/>
@@ -14140,17 +16727,17 @@
                         <a:buNone/>
                       </a:pPr>
                       <a:r>
-                        <a:rPr lang="en-US" sz="1200" dirty="0">
+                        <a:rPr lang="en-US" sz="1100" b="1" dirty="0">
                           <a:solidFill>
-                            <a:srgbClr val="1A1A2E"/>
+                            <a:srgbClr val="E74C3C"/>
                           </a:solidFill>
                         </a:rPr>
-                        <a:t>Pre-Dev + Phase 1 시작</a:t>
+                        <a:t>높음</a:t>
                       </a:r>
-                      <a:endParaRPr lang="en-US" sz="1200" dirty="0"/>
+                      <a:endParaRPr lang="en-US" sz="1100" dirty="0"/>
                     </a:p>
                   </a:txBody>
-                  <a:tcPr marL="152400" marR="152400" marT="101600" marB="101600">
+                  <a:tcPr marL="127000" marR="127000" marT="76200" marB="76200">
                     <a:lnL w="6350" cap="flat" cmpd="sng" algn="ctr">
                       <a:solidFill>
                         <a:srgbClr val="DDDDDD"/>
@@ -14201,17 +16788,17 @@
                         <a:buNone/>
                       </a:pPr>
                       <a:r>
-                        <a:rPr lang="en-US" sz="1200" dirty="0">
+                        <a:rPr lang="en-US" sz="1100" dirty="0">
                           <a:solidFill>
                             <a:srgbClr val="1A1A2E"/>
                           </a:solidFill>
                         </a:rPr>
-                        <a:t>BRD/PRD 완료, 개발 착수</a:t>
+                        <a:t>리뉴얼 + GTM 전략 (기존 13만 회원 활용)</a:t>
                       </a:r>
-                      <a:endParaRPr lang="en-US" sz="1200" dirty="0"/>
+                      <a:endParaRPr lang="en-US" sz="1100" dirty="0"/>
                     </a:p>
                   </a:txBody>
-                  <a:tcPr marL="152400" marR="152400" marT="101600" marB="101600">
+                  <a:tcPr marL="127000" marR="127000" marT="76200" marB="76200">
                     <a:lnL w="6350" cap="flat" cmpd="sng" algn="ctr">
                       <a:solidFill>
                         <a:srgbClr val="DDDDDD"/>
@@ -14264,17 +16851,17 @@
                         <a:buNone/>
                       </a:pPr>
                       <a:r>
-                        <a:rPr lang="en-US" sz="1200" dirty="0">
+                        <a:rPr lang="en-US" sz="1100" dirty="0">
                           <a:solidFill>
                             <a:srgbClr val="1A1A2E"/>
                           </a:solidFill>
                         </a:rPr>
-                        <a:t>2026 Q3</a:t>
+                        <a:t>iOS Wi-Fi 스캔 차단</a:t>
                       </a:r>
-                      <a:endParaRPr lang="en-US" sz="1200" dirty="0"/>
+                      <a:endParaRPr lang="en-US" sz="1100" dirty="0"/>
                     </a:p>
                   </a:txBody>
-                  <a:tcPr marL="152400" marR="152400" marT="101600" marB="101600">
+                  <a:tcPr marL="127000" marR="127000" marT="76200" marB="76200">
                     <a:lnL w="6350" cap="flat" cmpd="sng" algn="ctr">
                       <a:solidFill>
                         <a:srgbClr val="DDDDDD"/>
@@ -14325,17 +16912,17 @@
                         <a:buNone/>
                       </a:pPr>
                       <a:r>
-                        <a:rPr lang="en-US" sz="1200" dirty="0">
+                        <a:rPr lang="en-US" sz="1100" b="1" dirty="0">
                           <a:solidFill>
-                            <a:srgbClr val="1A1A2E"/>
+                            <a:srgbClr val="E74C3C"/>
                           </a:solidFill>
                         </a:rPr>
-                        <a:t>Phase 1 완료 + 출시</a:t>
+                        <a:t>높음</a:t>
                       </a:r>
-                      <a:endParaRPr lang="en-US" sz="1200" dirty="0"/>
+                      <a:endParaRPr lang="en-US" sz="1100" dirty="0"/>
                     </a:p>
                   </a:txBody>
-                  <a:tcPr marL="152400" marR="152400" marT="101600" marB="101600">
+                  <a:tcPr marL="127000" marR="127000" marT="76200" marB="76200">
                     <a:lnL w="6350" cap="flat" cmpd="sng" algn="ctr">
                       <a:solidFill>
                         <a:srgbClr val="DDDDDD"/>
@@ -14386,17 +16973,17 @@
                         <a:buNone/>
                       </a:pPr>
                       <a:r>
-                        <a:rPr lang="en-US" sz="1200" dirty="0">
+                        <a:rPr lang="en-US" sz="1100" dirty="0">
                           <a:solidFill>
                             <a:srgbClr val="1A1A2E"/>
                           </a:solidFill>
                         </a:rPr>
-                        <a:t>앱스토어 출시, MAU 10,000 목표</a:t>
+                        <a:t>GPS 속도 + 정류장 지오펜스 + CMMotion 대안</a:t>
                       </a:r>
-                      <a:endParaRPr lang="en-US" sz="1200" dirty="0"/>
+                      <a:endParaRPr lang="en-US" sz="1100" dirty="0"/>
                     </a:p>
                   </a:txBody>
-                  <a:tcPr marL="152400" marR="152400" marT="101600" marB="101600">
+                  <a:tcPr marL="127000" marR="127000" marT="76200" marB="76200">
                     <a:lnL w="6350" cap="flat" cmpd="sng" algn="ctr">
                       <a:solidFill>
                         <a:srgbClr val="DDDDDD"/>
@@ -14449,17 +17036,17 @@
                         <a:buNone/>
                       </a:pPr>
                       <a:r>
-                        <a:rPr lang="en-US" sz="1200" dirty="0">
+                        <a:rPr lang="en-US" sz="1100" dirty="0">
                           <a:solidFill>
                             <a:srgbClr val="1A1A2E"/>
                           </a:solidFill>
                         </a:rPr>
-                        <a:t>2026 Q4~2027 Q1</a:t>
+                        <a:t>1인 개발 체제</a:t>
                       </a:r>
-                      <a:endParaRPr lang="en-US" sz="1200" dirty="0"/>
+                      <a:endParaRPr lang="en-US" sz="1100" dirty="0"/>
                     </a:p>
                   </a:txBody>
-                  <a:tcPr marL="152400" marR="152400" marT="101600" marB="101600">
+                  <a:tcPr marL="127000" marR="127000" marT="76200" marB="76200">
                     <a:lnL w="6350" cap="flat" cmpd="sng" algn="ctr">
                       <a:solidFill>
                         <a:srgbClr val="DDDDDD"/>
@@ -14510,17 +17097,17 @@
                         <a:buNone/>
                       </a:pPr>
                       <a:r>
-                        <a:rPr lang="en-US" sz="1200" dirty="0">
+                        <a:rPr lang="en-US" sz="1100" b="1" dirty="0">
                           <a:solidFill>
                             <a:srgbClr val="1A1A2E"/>
                           </a:solidFill>
                         </a:rPr>
-                        <a:t>Phase 2 멀티스포츠</a:t>
+                        <a:t>중간</a:t>
                       </a:r>
-                      <a:endParaRPr lang="en-US" sz="1200" dirty="0"/>
+                      <a:endParaRPr lang="en-US" sz="1100" dirty="0"/>
                     </a:p>
                   </a:txBody>
-                  <a:tcPr marL="152400" marR="152400" marT="101600" marB="101600">
+                  <a:tcPr marL="127000" marR="127000" marT="76200" marB="76200">
                     <a:lnL w="6350" cap="flat" cmpd="sng" algn="ctr">
                       <a:solidFill>
                         <a:srgbClr val="DDDDDD"/>
@@ -14571,17 +17158,17 @@
                         <a:buNone/>
                       </a:pPr>
                       <a:r>
-                        <a:rPr lang="en-US" sz="1200" dirty="0">
+                        <a:rPr lang="en-US" sz="1100" dirty="0">
                           <a:solidFill>
                             <a:srgbClr val="1A1A2E"/>
                           </a:solidFill>
                         </a:rPr>
-                        <a:t>관광공사 MOU, 파크런 시작</a:t>
+                        <a:t>Claude AI 병렬 코드생성, Spec-Kit 자동화</a:t>
                       </a:r>
-                      <a:endParaRPr lang="en-US" sz="1200" dirty="0"/>
+                      <a:endParaRPr lang="en-US" sz="1100" dirty="0"/>
                     </a:p>
                   </a:txBody>
-                  <a:tcPr marL="152400" marR="152400" marT="101600" marB="101600">
+                  <a:tcPr marL="127000" marR="127000" marT="76200" marB="76200">
                     <a:lnL w="6350" cap="flat" cmpd="sng" algn="ctr">
                       <a:solidFill>
                         <a:srgbClr val="DDDDDD"/>
@@ -14634,17 +17221,17 @@
                         <a:buNone/>
                       </a:pPr>
                       <a:r>
-                        <a:rPr lang="en-US" sz="1200" dirty="0">
+                        <a:rPr lang="en-US" sz="1100" dirty="0">
                           <a:solidFill>
                             <a:srgbClr val="1A1A2E"/>
                           </a:solidFill>
                         </a:rPr>
-                        <a:t>2027 Q1~Q3</a:t>
+                        <a:t>STO 규제 불확실성</a:t>
                       </a:r>
-                      <a:endParaRPr lang="en-US" sz="1200" dirty="0"/>
+                      <a:endParaRPr lang="en-US" sz="1100" dirty="0"/>
                     </a:p>
                   </a:txBody>
-                  <a:tcPr marL="152400" marR="152400" marT="101600" marB="101600">
+                  <a:tcPr marL="127000" marR="127000" marT="76200" marB="76200">
                     <a:lnL w="6350" cap="flat" cmpd="sng" algn="ctr">
                       <a:solidFill>
                         <a:srgbClr val="DDDDDD"/>
@@ -14695,17 +17282,17 @@
                         <a:buNone/>
                       </a:pPr>
                       <a:r>
-                        <a:rPr lang="en-US" sz="1200" dirty="0">
+                        <a:rPr lang="en-US" sz="1100" b="1" dirty="0">
                           <a:solidFill>
                             <a:srgbClr val="1A1A2E"/>
                           </a:solidFill>
                         </a:rPr>
-                        <a:t>Phase 3 커머스</a:t>
+                        <a:t>중간</a:t>
                       </a:r>
-                      <a:endParaRPr lang="en-US" sz="1200" dirty="0"/>
+                      <a:endParaRPr lang="en-US" sz="1100" dirty="0"/>
                     </a:p>
                   </a:txBody>
-                  <a:tcPr marL="152400" marR="152400" marT="101600" marB="101600">
+                  <a:tcPr marL="127000" marR="127000" marT="76200" marB="76200">
                     <a:lnL w="6350" cap="flat" cmpd="sng" algn="ctr">
                       <a:solidFill>
                         <a:srgbClr val="DDDDDD"/>
@@ -14756,17 +17343,17 @@
                         <a:buNone/>
                       </a:pPr>
                       <a:r>
-                        <a:rPr lang="en-US" sz="1200" dirty="0">
+                        <a:rPr lang="en-US" sz="1100" dirty="0">
                           <a:solidFill>
                             <a:srgbClr val="1A1A2E"/>
                           </a:solidFill>
                         </a:rPr>
-                        <a:t>일반샵+깜깜이방, 매출 발생</a:t>
+                        <a:t>FSC 사전컨설팅 + 규제 샌드박스 참여</a:t>
                       </a:r>
-                      <a:endParaRPr lang="en-US" sz="1200" dirty="0"/>
+                      <a:endParaRPr lang="en-US" sz="1100" dirty="0"/>
                     </a:p>
                   </a:txBody>
-                  <a:tcPr marL="152400" marR="152400" marT="101600" marB="101600">
+                  <a:tcPr marL="127000" marR="127000" marT="76200" marB="76200">
                     <a:lnL w="6350" cap="flat" cmpd="sng" algn="ctr">
                       <a:solidFill>
                         <a:srgbClr val="DDDDDD"/>
@@ -14819,17 +17406,17 @@
                         <a:buNone/>
                       </a:pPr>
                       <a:r>
-                        <a:rPr lang="en-US" sz="1200" dirty="0">
+                        <a:rPr lang="en-US" sz="1100" dirty="0">
                           <a:solidFill>
                             <a:srgbClr val="1A1A2E"/>
                           </a:solidFill>
                         </a:rPr>
-                        <a:t>2027 Q3~2028 Q1</a:t>
+                        <a:t>딜러 익명성 유출</a:t>
                       </a:r>
-                      <a:endParaRPr lang="en-US" sz="1200" dirty="0"/>
+                      <a:endParaRPr lang="en-US" sz="1100" dirty="0"/>
                     </a:p>
                   </a:txBody>
-                  <a:tcPr marL="152400" marR="152400" marT="101600" marB="101600">
+                  <a:tcPr marL="127000" marR="127000" marT="76200" marB="76200">
                     <a:lnL w="6350" cap="flat" cmpd="sng" algn="ctr">
                       <a:solidFill>
                         <a:srgbClr val="DDDDDD"/>
@@ -14880,17 +17467,17 @@
                         <a:buNone/>
                       </a:pPr>
                       <a:r>
-                        <a:rPr lang="en-US" sz="1200" dirty="0">
+                        <a:rPr lang="en-US" sz="1100" b="1" dirty="0">
                           <a:solidFill>
-                            <a:srgbClr val="1A1A2E"/>
+                            <a:srgbClr val="E74C3C"/>
                           </a:solidFill>
                         </a:rPr>
-                        <a:t>Phase 4 STO</a:t>
+                        <a:t>높음</a:t>
                       </a:r>
-                      <a:endParaRPr lang="en-US" sz="1200" dirty="0"/>
+                      <a:endParaRPr lang="en-US" sz="1100" dirty="0"/>
                     </a:p>
                   </a:txBody>
-                  <a:tcPr marL="152400" marR="152400" marT="101600" marB="101600">
+                  <a:tcPr marL="127000" marR="127000" marT="76200" marB="76200">
                     <a:lnL w="6350" cap="flat" cmpd="sng" algn="ctr">
                       <a:solidFill>
                         <a:srgbClr val="DDDDDD"/>
@@ -14941,17 +17528,202 @@
                         <a:buNone/>
                       </a:pPr>
                       <a:r>
-                        <a:rPr lang="en-US" sz="1200" dirty="0">
+                        <a:rPr lang="en-US" sz="1100" dirty="0">
                           <a:solidFill>
                             <a:srgbClr val="1A1A2E"/>
                           </a:solidFill>
                         </a:rPr>
-                        <a:t>토큰증권 런칭, 글로벌 확장</a:t>
+                        <a:t>API 필터링 + 접근 제한 + 감사 로그</a:t>
                       </a:r>
-                      <a:endParaRPr lang="en-US" sz="1200" dirty="0"/>
+                      <a:endParaRPr lang="en-US" sz="1100" dirty="0"/>
                     </a:p>
                   </a:txBody>
-                  <a:tcPr marL="152400" marR="152400" marT="101600" marB="101600">
+                  <a:tcPr marL="127000" marR="127000" marT="76200" marB="76200">
+                    <a:lnL w="6350" cap="flat" cmpd="sng" algn="ctr">
+                      <a:solidFill>
+                        <a:srgbClr val="DDDDDD"/>
+                      </a:solidFill>
+                      <a:prstDash val="solid"/>
+                      <a:round/>
+                      <a:headEnd type="none" w="med" len="med"/>
+                      <a:tailEnd type="none" w="med" len="med"/>
+                    </a:lnL>
+                    <a:lnR w="6350" cap="flat" cmpd="sng" algn="ctr">
+                      <a:solidFill>
+                        <a:srgbClr val="DDDDDD"/>
+                      </a:solidFill>
+                      <a:prstDash val="solid"/>
+                      <a:round/>
+                      <a:headEnd type="none" w="med" len="med"/>
+                      <a:tailEnd type="none" w="med" len="med"/>
+                    </a:lnR>
+                    <a:lnT w="6350" cap="flat" cmpd="sng" algn="ctr">
+                      <a:solidFill>
+                        <a:srgbClr val="DDDDDD"/>
+                      </a:solidFill>
+                      <a:prstDash val="solid"/>
+                      <a:round/>
+                      <a:headEnd type="none" w="med" len="med"/>
+                      <a:tailEnd type="none" w="med" len="med"/>
+                    </a:lnT>
+                    <a:lnB w="6350" cap="flat" cmpd="sng" algn="ctr">
+                      <a:solidFill>
+                        <a:srgbClr val="DDDDDD"/>
+                      </a:solidFill>
+                      <a:prstDash val="solid"/>
+                      <a:round/>
+                      <a:headEnd type="none" w="med" len="med"/>
+                      <a:tailEnd type="none" w="med" len="med"/>
+                    </a:lnB>
+                    <a:solidFill>
+                      <a:srgbClr val="F8F9FA"/>
+                    </a:solidFill>
+                  </a:tcPr>
+                </a:tc>
+              </a:tr>
+              <a:tr h="0">
+                <a:tc>
+                  <a:txBody>
+                    <a:bodyPr/>
+                    <a:lstStyle/>
+                    <a:p>
+                      <a:pPr indent="0" marL="0">
+                        <a:buNone/>
+                      </a:pPr>
+                      <a:r>
+                        <a:rPr lang="en-US" sz="1100" dirty="0">
+                          <a:solidFill>
+                            <a:srgbClr val="1A1A2E"/>
+                          </a:solidFill>
+                        </a:rPr>
+                        <a:t>토큰 가격 붕괴</a:t>
+                      </a:r>
+                      <a:endParaRPr lang="en-US" sz="1100" dirty="0"/>
+                    </a:p>
+                  </a:txBody>
+                  <a:tcPr marL="127000" marR="127000" marT="76200" marB="76200">
+                    <a:lnL w="6350" cap="flat" cmpd="sng" algn="ctr">
+                      <a:solidFill>
+                        <a:srgbClr val="DDDDDD"/>
+                      </a:solidFill>
+                      <a:prstDash val="solid"/>
+                      <a:round/>
+                      <a:headEnd type="none" w="med" len="med"/>
+                      <a:tailEnd type="none" w="med" len="med"/>
+                    </a:lnL>
+                    <a:lnR w="6350" cap="flat" cmpd="sng" algn="ctr">
+                      <a:solidFill>
+                        <a:srgbClr val="DDDDDD"/>
+                      </a:solidFill>
+                      <a:prstDash val="solid"/>
+                      <a:round/>
+                      <a:headEnd type="none" w="med" len="med"/>
+                      <a:tailEnd type="none" w="med" len="med"/>
+                    </a:lnR>
+                    <a:lnT w="6350" cap="flat" cmpd="sng" algn="ctr">
+                      <a:solidFill>
+                        <a:srgbClr val="DDDDDD"/>
+                      </a:solidFill>
+                      <a:prstDash val="solid"/>
+                      <a:round/>
+                      <a:headEnd type="none" w="med" len="med"/>
+                      <a:tailEnd type="none" w="med" len="med"/>
+                    </a:lnT>
+                    <a:lnB w="6350" cap="flat" cmpd="sng" algn="ctr">
+                      <a:solidFill>
+                        <a:srgbClr val="DDDDDD"/>
+                      </a:solidFill>
+                      <a:prstDash val="solid"/>
+                      <a:round/>
+                      <a:headEnd type="none" w="med" len="med"/>
+                      <a:tailEnd type="none" w="med" len="med"/>
+                    </a:lnB>
+                    <a:solidFill>
+                      <a:srgbClr val="F8F9FA"/>
+                    </a:solidFill>
+                  </a:tcPr>
+                </a:tc>
+                <a:tc>
+                  <a:txBody>
+                    <a:bodyPr/>
+                    <a:lstStyle/>
+                    <a:p>
+                      <a:pPr indent="0" marL="0">
+                        <a:buNone/>
+                      </a:pPr>
+                      <a:r>
+                        <a:rPr lang="en-US" sz="1100" b="1" dirty="0">
+                          <a:solidFill>
+                            <a:srgbClr val="1A1A2E"/>
+                          </a:solidFill>
+                        </a:rPr>
+                        <a:t>중간</a:t>
+                      </a:r>
+                      <a:endParaRPr lang="en-US" sz="1100" dirty="0"/>
+                    </a:p>
+                  </a:txBody>
+                  <a:tcPr marL="127000" marR="127000" marT="76200" marB="76200">
+                    <a:lnL w="6350" cap="flat" cmpd="sng" algn="ctr">
+                      <a:solidFill>
+                        <a:srgbClr val="DDDDDD"/>
+                      </a:solidFill>
+                      <a:prstDash val="solid"/>
+                      <a:round/>
+                      <a:headEnd type="none" w="med" len="med"/>
+                      <a:tailEnd type="none" w="med" len="med"/>
+                    </a:lnL>
+                    <a:lnR w="6350" cap="flat" cmpd="sng" algn="ctr">
+                      <a:solidFill>
+                        <a:srgbClr val="DDDDDD"/>
+                      </a:solidFill>
+                      <a:prstDash val="solid"/>
+                      <a:round/>
+                      <a:headEnd type="none" w="med" len="med"/>
+                      <a:tailEnd type="none" w="med" len="med"/>
+                    </a:lnR>
+                    <a:lnT w="6350" cap="flat" cmpd="sng" algn="ctr">
+                      <a:solidFill>
+                        <a:srgbClr val="DDDDDD"/>
+                      </a:solidFill>
+                      <a:prstDash val="solid"/>
+                      <a:round/>
+                      <a:headEnd type="none" w="med" len="med"/>
+                      <a:tailEnd type="none" w="med" len="med"/>
+                    </a:lnT>
+                    <a:lnB w="6350" cap="flat" cmpd="sng" algn="ctr">
+                      <a:solidFill>
+                        <a:srgbClr val="DDDDDD"/>
+                      </a:solidFill>
+                      <a:prstDash val="solid"/>
+                      <a:round/>
+                      <a:headEnd type="none" w="med" len="med"/>
+                      <a:tailEnd type="none" w="med" len="med"/>
+                    </a:lnB>
+                    <a:solidFill>
+                      <a:srgbClr val="F8F9FA"/>
+                    </a:solidFill>
+                  </a:tcPr>
+                </a:tc>
+                <a:tc>
+                  <a:txBody>
+                    <a:bodyPr/>
+                    <a:lstStyle/>
+                    <a:p>
+                      <a:pPr indent="0" marL="0">
+                        <a:buNone/>
+                      </a:pPr>
+                      <a:r>
+                        <a:rPr lang="en-US" sz="1100" dirty="0">
+                          <a:solidFill>
+                            <a:srgbClr val="1A1A2E"/>
+                          </a:solidFill>
+                        </a:rPr>
+                        <a:t>STO 구조로 투기 제한 + 소각 메커니즘</a:t>
+                      </a:r>
+                      <a:endParaRPr lang="en-US" sz="1100" dirty="0"/>
+                    </a:p>
+                  </a:txBody>
+                  <a:tcPr marL="127000" marR="127000" marT="76200" marB="76200">
                     <a:lnL w="6350" cap="flat" cmpd="sng" algn="ctr">
                       <a:solidFill>
                         <a:srgbClr val="DDDDDD"/>
@@ -14998,145 +17770,6 @@
           </a:graphicData>
         </a:graphic>
       </p:graphicFrame>
-      <p:sp>
-        <p:nvSpPr>
-          <p:cNvPr id="4" name="Shape 1"/>
-          <p:cNvSpPr/>
-          <p:nvPr/>
-        </p:nvSpPr>
-        <p:spPr>
-          <a:xfrm>
-            <a:off x="2743200" y="5029200"/>
-            <a:ext cx="6400800" cy="1371600"/>
-          </a:xfrm>
-          <a:prstGeom prst="roundRect">
-            <a:avLst>
-              <a:gd name="adj" fmla="val 10000"/>
-            </a:avLst>
-          </a:prstGeom>
-          <a:solidFill>
-            <a:srgbClr val="1E2761"/>
-          </a:solidFill>
-          <a:ln/>
-        </p:spPr>
-      </p:sp>
-      <p:sp>
-        <p:nvSpPr>
-          <p:cNvPr id="5" name="Text 2"/>
-          <p:cNvSpPr/>
-          <p:nvPr/>
-        </p:nvSpPr>
-        <p:spPr>
-          <a:xfrm>
-            <a:off x="2743200" y="5120640"/>
-            <a:ext cx="6400800" cy="0"/>
-          </a:xfrm>
-          <a:prstGeom prst="rect">
-            <a:avLst/>
-          </a:prstGeom>
-          <a:noFill/>
-          <a:ln/>
-        </p:spPr>
-        <p:txBody>
-          <a:bodyPr wrap="square" rtlCol="0" anchor="ctr"/>
-          <a:lstStyle/>
-          <a:p>
-            <a:pPr algn="ctr" indent="0" marL="0">
-              <a:buNone/>
-            </a:pPr>
-            <a:r>
-              <a:rPr lang="en-US" sz="1200" dirty="0">
-                <a:solidFill>
-                  <a:srgbClr val="95A5A6"/>
-                </a:solidFill>
-                <a:latin typeface="Arial" pitchFamily="34" charset="0"/>
-                <a:ea typeface="Arial" pitchFamily="34" charset="-122"/>
-                <a:cs typeface="Arial" pitchFamily="34" charset="-120"/>
-              </a:rPr>
-              <a:t>총 개발 기간</a:t>
-            </a:r>
-            <a:endParaRPr lang="en-US" sz="1200" dirty="0"/>
-          </a:p>
-        </p:txBody>
-      </p:sp>
-      <p:sp>
-        <p:nvSpPr>
-          <p:cNvPr id="6" name="Text 3"/>
-          <p:cNvSpPr/>
-          <p:nvPr/>
-        </p:nvSpPr>
-        <p:spPr>
-          <a:xfrm>
-            <a:off x="2743200" y="5394960"/>
-            <a:ext cx="6400800" cy="0"/>
-          </a:xfrm>
-          <a:prstGeom prst="rect">
-            <a:avLst/>
-          </a:prstGeom>
-          <a:noFill/>
-          <a:ln/>
-        </p:spPr>
-        <p:txBody>
-          <a:bodyPr wrap="square" rtlCol="0" anchor="ctr"/>
-          <a:lstStyle/>
-          <a:p>
-            <a:pPr algn="ctr" indent="0" marL="0">
-              <a:buNone/>
-            </a:pPr>
-            <a:r>
-              <a:rPr lang="en-US" sz="3200" b="1" dirty="0">
-                <a:solidFill>
-                  <a:srgbClr val="FFFFFF"/>
-                </a:solidFill>
-                <a:latin typeface="Arial Black" pitchFamily="34" charset="0"/>
-                <a:ea typeface="Arial Black" pitchFamily="34" charset="-122"/>
-                <a:cs typeface="Arial Black" pitchFamily="34" charset="-120"/>
-              </a:rPr>
-              <a:t>73주 (약 18개월)</a:t>
-            </a:r>
-            <a:endParaRPr lang="en-US" sz="3200" dirty="0"/>
-          </a:p>
-        </p:txBody>
-      </p:sp>
-      <p:sp>
-        <p:nvSpPr>
-          <p:cNvPr id="7" name="Text 4"/>
-          <p:cNvSpPr/>
-          <p:nvPr/>
-        </p:nvSpPr>
-        <p:spPr>
-          <a:xfrm>
-            <a:off x="2743200" y="5943600"/>
-            <a:ext cx="6400800" cy="0"/>
-          </a:xfrm>
-          <a:prstGeom prst="rect">
-            <a:avLst/>
-          </a:prstGeom>
-          <a:noFill/>
-          <a:ln/>
-        </p:spPr>
-        <p:txBody>
-          <a:bodyPr wrap="square" rtlCol="0" anchor="ctr"/>
-          <a:lstStyle/>
-          <a:p>
-            <a:pPr algn="ctr" indent="0" marL="0">
-              <a:buNone/>
-            </a:pPr>
-            <a:r>
-              <a:rPr lang="en-US" sz="1400" dirty="0">
-                <a:solidFill>
-                  <a:srgbClr val="27AE60"/>
-                </a:solidFill>
-                <a:latin typeface="Arial" pitchFamily="34" charset="0"/>
-                <a:ea typeface="Arial" pitchFamily="34" charset="-122"/>
-                <a:cs typeface="Arial" pitchFamily="34" charset="-120"/>
-              </a:rPr>
-              <a:t>가속 시 56~62주 (약 14~15.5개월)</a:t>
-            </a:r>
-            <a:endParaRPr lang="en-US" sz="1400" dirty="0"/>
-          </a:p>
-        </p:txBody>
-      </p:sp>
     </p:spTree>
   </p:cSld>
   <p:clrMapOvr>

</xml_diff>